<commit_message>
feat(presentation): update preliminary presentation file
</commit_message>
<xml_diff>
--- a/docs/apresentacao_preliminar/presentation.pptx
+++ b/docs/apresentacao_preliminar/presentation.pptx
@@ -10511,7 +10511,7 @@
             </a:r>
             <a:r>
               <a:rPr lang="pt-BR" sz="1100" b="1" dirty="0"/>
-              <a:t>65,15 km</a:t>
+              <a:t>59,60 km</a:t>
             </a:r>
             <a:r>
               <a:rPr lang="pt-BR" sz="1100" dirty="0"/>
@@ -11212,7 +11212,7 @@
             </a:r>
             <a:r>
               <a:rPr lang="pt-BR" sz="1100" b="1" dirty="0"/>
-              <a:t>92,21 km</a:t>
+              <a:t>86,17 km</a:t>
             </a:r>
             <a:r>
               <a:rPr lang="pt-BR" sz="1100" dirty="0"/>
@@ -11230,7 +11230,7 @@
             </a:r>
             <a:r>
               <a:rPr lang="pt-BR" sz="1100" b="1" dirty="0"/>
-              <a:t>40,09 L</a:t>
+              <a:t>37,47 L</a:t>
             </a:r>
             <a:r>
               <a:rPr lang="pt-BR" sz="1100" dirty="0"/>
@@ -11248,7 +11248,7 @@
             </a:r>
             <a:r>
               <a:rPr lang="pt-BR" sz="1100" b="1" dirty="0"/>
-              <a:t>107,44 kg </a:t>
+              <a:t>100,41 kg </a:t>
             </a:r>
             <a:r>
               <a:rPr lang="pt-BR" sz="1100" b="1" dirty="0" err="1"/>
@@ -11270,7 +11270,7 @@
             </a:r>
             <a:r>
               <a:rPr lang="pt-BR" sz="1100" b="1" dirty="0"/>
-              <a:t>R$ 275,23</a:t>
+              <a:t>R$ 257,20</a:t>
             </a:r>
             <a:r>
               <a:rPr lang="pt-BR" sz="1100" dirty="0"/>
@@ -11416,8 +11416,8 @@
           <a:chExt cx="0" cy="0"/>
         </a:xfrm>
       </p:grpSpPr>
-      <mc:AlternateContent xmlns:mc="http://schemas.openxmlformats.org/markup-compatibility/2006">
-        <mc:Choice xmlns:a14="http://schemas.microsoft.com/office/drawing/2010/main" Requires="a14">
+      <mc:AlternateContent xmlns:mc="http://schemas.openxmlformats.org/markup-compatibility/2006" xmlns:a14="http://schemas.microsoft.com/office/drawing/2010/main">
+        <mc:Choice Requires="a14">
           <p:sp>
             <p:nvSpPr>
               <p:cNvPr id="364" name="Google Shape;364;p38">
@@ -11925,7 +11925,7 @@
             </p:txBody>
           </p:sp>
         </mc:Choice>
-        <mc:Fallback>
+        <mc:Fallback xmlns="">
           <p:sp>
             <p:nvSpPr>
               <p:cNvPr id="364" name="Google Shape;364;p38">
@@ -12444,9 +12444,8 @@
           <a:p>
             <a:r>
               <a:rPr lang="pt-BR" sz="1100" b="1" dirty="0"/>
-              <a:t>Total das operações portuárias</a:t>
+              <a:t>Operações portuárias contabilizadas</a:t>
             </a:r>
-            <a:endParaRPr lang="pt-BR" sz="1100" dirty="0"/>
           </a:p>
           <a:p>
             <a:pPr>
@@ -12505,8 +12504,8 @@
           </a:p>
         </p:txBody>
       </p:sp>
-      <mc:AlternateContent xmlns:mc="http://schemas.openxmlformats.org/markup-compatibility/2006">
-        <mc:Choice xmlns:a14="http://schemas.microsoft.com/office/drawing/2010/main" Requires="a14">
+      <mc:AlternateContent xmlns:mc="http://schemas.openxmlformats.org/markup-compatibility/2006" xmlns:a14="http://schemas.microsoft.com/office/drawing/2010/main">
+        <mc:Choice Requires="a14">
           <p:sp>
             <p:nvSpPr>
               <p:cNvPr id="446" name="Google Shape;446;p43">
@@ -12744,7 +12743,7 @@
             </p:txBody>
           </p:sp>
         </mc:Choice>
-        <mc:Fallback>
+        <mc:Fallback xmlns="">
           <p:sp>
             <p:nvSpPr>
               <p:cNvPr id="446" name="Google Shape;446;p43">
@@ -13195,8 +13194,8 @@
           <a:chExt cx="0" cy="0"/>
         </a:xfrm>
       </p:grpSpPr>
-      <mc:AlternateContent xmlns:mc="http://schemas.openxmlformats.org/markup-compatibility/2006">
-        <mc:Choice xmlns:a14="http://schemas.microsoft.com/office/drawing/2010/main" Requires="a14">
+      <mc:AlternateContent xmlns:mc="http://schemas.openxmlformats.org/markup-compatibility/2006" xmlns:a14="http://schemas.microsoft.com/office/drawing/2010/main">
+        <mc:Choice Requires="a14">
           <p:sp>
             <p:nvSpPr>
               <p:cNvPr id="364" name="Google Shape;364;p38">
@@ -13977,7 +13976,7 @@
             </p:txBody>
           </p:sp>
         </mc:Choice>
-        <mc:Fallback>
+        <mc:Fallback xmlns="">
           <p:sp>
             <p:nvSpPr>
               <p:cNvPr id="364" name="Google Shape;364;p38">
@@ -15131,7 +15130,7 @@
             </a:pPr>
             <a:r>
               <a:rPr lang="pt-BR" dirty="0"/>
-              <a:t>Distribuição espacial do potencial de redução de emissões</a:t>
+              <a:t>Distribuição espacial do potencial de redução do consumo de combustível</a:t>
             </a:r>
             <a:endParaRPr dirty="0"/>
           </a:p>
@@ -15230,11 +15229,19 @@
             </a:r>
             <a:r>
               <a:rPr lang="pt-BR" b="1" dirty="0"/>
-              <a:t>Avenida Professor Luciano Gualberto, São Paulo</a:t>
+              <a:t>Avenida Professor Luciano Gualberto, em São Paulo</a:t>
             </a:r>
             <a:r>
               <a:rPr lang="pt-BR" dirty="0"/>
-              <a:t> — o pipeline compara as alternativas </a:t>
+              <a:t> — e uma carga de </a:t>
+            </a:r>
+            <a:r>
+              <a:rPr lang="pt-BR" b="1" dirty="0"/>
+              <a:t>14 toneladas</a:t>
+            </a:r>
+            <a:r>
+              <a:rPr lang="pt-BR" dirty="0"/>
+              <a:t>, o pipeline executa a comparação entre as alternativas </a:t>
             </a:r>
             <a:r>
               <a:rPr lang="pt-BR" b="1" dirty="0"/>
@@ -15250,11 +15257,11 @@
             </a:r>
             <a:r>
               <a:rPr lang="pt-BR" dirty="0"/>
-              <a:t> para uma lista de cidades de destino, considerando uma carga de </a:t>
+              <a:t> para uma lista de cidades de destino</a:t>
             </a:r>
             <a:r>
               <a:rPr lang="pt-BR" b="1" dirty="0"/>
-              <a:t>14 toneladas.</a:t>
+              <a:t>.</a:t>
             </a:r>
           </a:p>
           <a:p>
@@ -15269,21 +15276,16 @@
             </a:pPr>
             <a:r>
               <a:rPr lang="pt-BR" dirty="0"/>
-              <a:t>Os resultados são consolidados em um mapa de calor, permitindo identificar as regiões em que a </a:t>
+              <a:t>Os resultados são consolidados em um mapa de calor, permitindo visualizar os destinos em que a alternativa multimodal apresenta </a:t>
             </a:r>
             <a:r>
               <a:rPr lang="pt-BR" b="1" dirty="0"/>
-              <a:t>cabotagem reduz o consumo de combustível</a:t>
+              <a:t>menor consumo de combustível</a:t>
             </a:r>
             <a:r>
               <a:rPr lang="pt-BR" dirty="0"/>
-              <a:t> e aquelas em que o </a:t>
+              <a:t> e aqueles em que o transporte rodoviário direto permanece mais eficiente.</a:t>
             </a:r>
-            <a:r>
-              <a:rPr lang="pt-BR" b="1" dirty="0"/>
-              <a:t>transporte rodoviário direto permanece mais eficiente.</a:t>
-            </a:r>
-            <a:endParaRPr lang="pt-BR" dirty="0"/>
           </a:p>
         </p:txBody>
       </p:sp>

</xml_diff>

<commit_message>
docs(methodology): tornar relatórios marítimos mais didáticos
</commit_message>
<xml_diff>
--- a/docs/apresentacao_preliminar/presentation.pptx
+++ b/docs/apresentacao_preliminar/presentation.pptx
@@ -5,7 +5,7 @@
     <p:sldMasterId id="2147483680" r:id="rId1"/>
   </p:sldMasterIdLst>
   <p:notesMasterIdLst>
-    <p:notesMasterId r:id="rId19"/>
+    <p:notesMasterId r:id="rId20"/>
   </p:notesMasterIdLst>
   <p:sldIdLst>
     <p:sldId id="302" r:id="rId2"/>
@@ -21,29 +21,30 @@
     <p:sldId id="314" r:id="rId12"/>
     <p:sldId id="313" r:id="rId13"/>
     <p:sldId id="315" r:id="rId14"/>
-    <p:sldId id="316" r:id="rId15"/>
-    <p:sldId id="317" r:id="rId16"/>
-    <p:sldId id="318" r:id="rId17"/>
-    <p:sldId id="320" r:id="rId18"/>
+    <p:sldId id="321" r:id="rId15"/>
+    <p:sldId id="316" r:id="rId16"/>
+    <p:sldId id="317" r:id="rId17"/>
+    <p:sldId id="318" r:id="rId18"/>
+    <p:sldId id="320" r:id="rId19"/>
   </p:sldIdLst>
   <p:sldSz cx="9144000" cy="5143500" type="screen16x9"/>
   <p:notesSz cx="6858000" cy="9144000"/>
   <p:embeddedFontLst>
     <p:embeddedFont>
       <p:font typeface="Cambria Math" panose="02040503050406030204" pitchFamily="18" charset="0"/>
-      <p:regular r:id="rId20"/>
+      <p:regular r:id="rId21"/>
     </p:embeddedFont>
     <p:embeddedFont>
       <p:font typeface="Nunito Light" pitchFamily="2" charset="0"/>
-      <p:regular r:id="rId21"/>
-      <p:italic r:id="rId22"/>
+      <p:regular r:id="rId22"/>
+      <p:italic r:id="rId23"/>
     </p:embeddedFont>
     <p:embeddedFont>
       <p:font typeface="Poppins" panose="00000500000000000000" pitchFamily="2" charset="0"/>
-      <p:regular r:id="rId23"/>
-      <p:bold r:id="rId24"/>
-      <p:italic r:id="rId25"/>
-      <p:boldItalic r:id="rId26"/>
+      <p:regular r:id="rId24"/>
+      <p:bold r:id="rId25"/>
+      <p:italic r:id="rId26"/>
+      <p:boldItalic r:id="rId27"/>
     </p:embeddedFont>
   </p:embeddedFontLst>
   <p:defaultTextStyle>
@@ -305,6 +306,7 @@
             <p14:sldId id="314"/>
             <p14:sldId id="313"/>
             <p14:sldId id="315"/>
+            <p14:sldId id="321"/>
             <p14:sldId id="316"/>
           </p14:sldIdLst>
         </p14:section>
@@ -14327,6 +14329,72 @@
   <p:cSld>
     <p:spTree>
       <p:nvGrpSpPr>
+        <p:cNvPr id="1" name=""/>
+        <p:cNvGrpSpPr/>
+        <p:nvPr/>
+      </p:nvGrpSpPr>
+      <p:grpSpPr>
+        <a:xfrm>
+          <a:off x="0" y="0"/>
+          <a:ext cx="0" cy="0"/>
+          <a:chOff x="0" y="0"/>
+          <a:chExt cx="0" cy="0"/>
+        </a:xfrm>
+      </p:grpSpPr>
+      <p:pic>
+        <p:nvPicPr>
+          <p:cNvPr id="9" name="Gráfico 8" descr="Tabela com preenchimento sólido">
+            <a:extLst>
+              <a:ext uri="{FF2B5EF4-FFF2-40B4-BE49-F238E27FC236}">
+                <a16:creationId xmlns:a16="http://schemas.microsoft.com/office/drawing/2014/main" id="{8FF78EA9-05BB-A842-73DB-89C93448BE6B}"/>
+              </a:ext>
+            </a:extLst>
+          </p:cNvPr>
+          <p:cNvPicPr>
+            <a:picLocks noChangeAspect="1"/>
+          </p:cNvPicPr>
+          <p:nvPr/>
+        </p:nvPicPr>
+        <p:blipFill>
+          <a:blip>
+            <a:extLst>
+              <a:ext uri="{96DAC541-7B7A-43D3-8B79-37D633B846F1}">
+                <asvg:svgBlip xmlns:asvg="http://schemas.microsoft.com/office/drawing/2016/SVG/main" r:embed="rId2"/>
+              </a:ext>
+            </a:extLst>
+          </a:blip>
+          <a:stretch>
+            <a:fillRect/>
+          </a:stretch>
+        </p:blipFill>
+        <p:spPr>
+          <a:xfrm>
+            <a:off x="781462" y="1991509"/>
+            <a:ext cx="914400" cy="914400"/>
+          </a:xfrm>
+          <a:prstGeom prst="rect">
+            <a:avLst/>
+          </a:prstGeom>
+        </p:spPr>
+      </p:pic>
+    </p:spTree>
+    <p:extLst>
+      <p:ext uri="{BB962C8B-B14F-4D97-AF65-F5344CB8AC3E}">
+        <p14:creationId xmlns:p14="http://schemas.microsoft.com/office/powerpoint/2010/main" val="2935875827"/>
+      </p:ext>
+    </p:extLst>
+  </p:cSld>
+  <p:clrMapOvr>
+    <a:masterClrMapping/>
+  </p:clrMapOvr>
+</p:sld>
+</file>
+
+<file path=ppt/slides/slide15.xml><?xml version="1.0" encoding="utf-8"?>
+<p:sld xmlns:a="http://schemas.openxmlformats.org/drawingml/2006/main" xmlns:r="http://schemas.openxmlformats.org/officeDocument/2006/relationships" xmlns:p="http://schemas.openxmlformats.org/presentationml/2006/main">
+  <p:cSld>
+    <p:spTree>
+      <p:nvGrpSpPr>
         <p:cNvPr id="1" name="Shape 482">
           <a:extLst>
             <a:ext uri="{FF2B5EF4-FFF2-40B4-BE49-F238E27FC236}">
@@ -15017,7 +15085,7 @@
 </p:sld>
 </file>
 
-<file path=ppt/slides/slide15.xml><?xml version="1.0" encoding="utf-8"?>
+<file path=ppt/slides/slide16.xml><?xml version="1.0" encoding="utf-8"?>
 <p:sld xmlns:a="http://schemas.openxmlformats.org/drawingml/2006/main" xmlns:r="http://schemas.openxmlformats.org/officeDocument/2006/relationships" xmlns:p="http://schemas.openxmlformats.org/presentationml/2006/main">
   <p:cSld>
     <p:spTree>
@@ -15149,7 +15217,7 @@
 </p:sld>
 </file>
 
-<file path=ppt/slides/slide16.xml><?xml version="1.0" encoding="utf-8"?>
+<file path=ppt/slides/slide17.xml><?xml version="1.0" encoding="utf-8"?>
 <p:sld xmlns:a="http://schemas.openxmlformats.org/drawingml/2006/main" xmlns:r="http://schemas.openxmlformats.org/officeDocument/2006/relationships" xmlns:p="http://schemas.openxmlformats.org/presentationml/2006/main">
   <p:cSld>
     <p:spTree>
@@ -15451,7 +15519,7 @@
 </p:sld>
 </file>
 
-<file path=ppt/slides/slide17.xml><?xml version="1.0" encoding="utf-8"?>
+<file path=ppt/slides/slide18.xml><?xml version="1.0" encoding="utf-8"?>
 <p:sld xmlns:a="http://schemas.openxmlformats.org/drawingml/2006/main" xmlns:r="http://schemas.openxmlformats.org/officeDocument/2006/relationships" xmlns:p="http://schemas.openxmlformats.org/presentationml/2006/main">
   <p:cSld>
     <p:spTree>

</xml_diff>

<commit_message>
feat: add audit logging for voyage efficiency calculations
- Introduced `audit_voyage_ids` parameter in `refresh_antaq_pipeline` and `enrich_sea_matrix_with_efficiency` functions to enable detailed logging for specified voyages.
- Enhanced logging in the `sea_matrix_efficiency` module to capture intermediate values during voyage reconstruction, including cargo, distance, transport work, intensity, and fuel consumption.
- Updated command-line interfaces in `refresh_antaq_pipeline.py` and `enrich_sea_matrix_with_voyage_efficiency.py` to accept `--audit-voyage-id` argument for specifying voyages to audit.
- Added unit tests to verify the correctness of the audit logging and ensure that reconstructed values match expected results.
</commit_message>
<xml_diff>
--- a/docs/apresentacao_preliminar/presentation.pptx
+++ b/docs/apresentacao_preliminar/presentation.pptx
@@ -5,7 +5,7 @@
     <p:sldMasterId id="2147483680" r:id="rId1"/>
   </p:sldMasterIdLst>
   <p:notesMasterIdLst>
-    <p:notesMasterId r:id="rId20"/>
+    <p:notesMasterId r:id="rId24"/>
   </p:notesMasterIdLst>
   <p:sldIdLst>
     <p:sldId id="302" r:id="rId2"/>
@@ -16,35 +16,44 @@
     <p:sldId id="308" r:id="rId7"/>
     <p:sldId id="306" r:id="rId8"/>
     <p:sldId id="309" r:id="rId9"/>
-    <p:sldId id="310" r:id="rId10"/>
-    <p:sldId id="312" r:id="rId11"/>
-    <p:sldId id="314" r:id="rId12"/>
-    <p:sldId id="313" r:id="rId13"/>
-    <p:sldId id="315" r:id="rId14"/>
-    <p:sldId id="321" r:id="rId15"/>
-    <p:sldId id="316" r:id="rId16"/>
-    <p:sldId id="317" r:id="rId17"/>
-    <p:sldId id="318" r:id="rId18"/>
-    <p:sldId id="320" r:id="rId19"/>
+    <p:sldId id="324" r:id="rId10"/>
+    <p:sldId id="310" r:id="rId11"/>
+    <p:sldId id="312" r:id="rId12"/>
+    <p:sldId id="314" r:id="rId13"/>
+    <p:sldId id="313" r:id="rId14"/>
+    <p:sldId id="258" r:id="rId15"/>
+    <p:sldId id="323" r:id="rId16"/>
+    <p:sldId id="315" r:id="rId17"/>
+    <p:sldId id="322" r:id="rId18"/>
+    <p:sldId id="321" r:id="rId19"/>
+    <p:sldId id="316" r:id="rId20"/>
+    <p:sldId id="317" r:id="rId21"/>
+    <p:sldId id="318" r:id="rId22"/>
+    <p:sldId id="320" r:id="rId23"/>
   </p:sldIdLst>
   <p:sldSz cx="9144000" cy="5143500" type="screen16x9"/>
   <p:notesSz cx="6858000" cy="9144000"/>
   <p:embeddedFontLst>
     <p:embeddedFont>
+      <p:font typeface="Anaheim" panose="020B0604020202020204" charset="0"/>
+      <p:regular r:id="rId25"/>
+      <p:bold r:id="rId26"/>
+    </p:embeddedFont>
+    <p:embeddedFont>
       <p:font typeface="Cambria Math" panose="02040503050406030204" pitchFamily="18" charset="0"/>
-      <p:regular r:id="rId21"/>
+      <p:regular r:id="rId27"/>
     </p:embeddedFont>
     <p:embeddedFont>
       <p:font typeface="Nunito Light" pitchFamily="2" charset="0"/>
-      <p:regular r:id="rId22"/>
-      <p:italic r:id="rId23"/>
+      <p:regular r:id="rId28"/>
+      <p:italic r:id="rId29"/>
     </p:embeddedFont>
     <p:embeddedFont>
       <p:font typeface="Poppins" panose="00000500000000000000" pitchFamily="2" charset="0"/>
-      <p:regular r:id="rId24"/>
-      <p:bold r:id="rId25"/>
-      <p:italic r:id="rId26"/>
-      <p:boldItalic r:id="rId27"/>
+      <p:regular r:id="rId30"/>
+      <p:bold r:id="rId31"/>
+      <p:italic r:id="rId32"/>
+      <p:boldItalic r:id="rId33"/>
     </p:embeddedFont>
   </p:embeddedFontLst>
   <p:defaultTextStyle>
@@ -301,11 +310,15 @@
         </p14:section>
         <p14:section name="Alternativa multimodal" id="{7889494C-5226-4D7C-B44C-E5D8D40188A9}">
           <p14:sldIdLst>
+            <p14:sldId id="324"/>
             <p14:sldId id="310"/>
             <p14:sldId id="312"/>
             <p14:sldId id="314"/>
             <p14:sldId id="313"/>
+            <p14:sldId id="258"/>
+            <p14:sldId id="323"/>
             <p14:sldId id="315"/>
+            <p14:sldId id="322"/>
             <p14:sldId id="321"/>
             <p14:sldId id="316"/>
           </p14:sldIdLst>
@@ -1315,6 +1328,135 @@
   <p:cSld>
     <p:spTree>
       <p:nvGrpSpPr>
+        <p:cNvPr id="1" name="Shape 340"/>
+        <p:cNvGrpSpPr/>
+        <p:nvPr/>
+      </p:nvGrpSpPr>
+      <p:grpSpPr>
+        <a:xfrm>
+          <a:off x="0" y="0"/>
+          <a:ext cx="0" cy="0"/>
+          <a:chOff x="0" y="0"/>
+          <a:chExt cx="0" cy="0"/>
+        </a:xfrm>
+      </p:grpSpPr>
+      <p:sp>
+        <p:nvSpPr>
+          <p:cNvPr id="341" name="Google Shape;341;gd431007ba2_0_215:notes"/>
+          <p:cNvSpPr>
+            <a:spLocks noGrp="1" noRot="1" noChangeAspect="1"/>
+          </p:cNvSpPr>
+          <p:nvPr>
+            <p:ph type="sldImg" idx="2"/>
+          </p:nvPr>
+        </p:nvSpPr>
+        <p:spPr>
+          <a:xfrm>
+            <a:off x="381000" y="685800"/>
+            <a:ext cx="6096000" cy="3429000"/>
+          </a:xfrm>
+          <a:custGeom>
+            <a:avLst/>
+            <a:gdLst/>
+            <a:ahLst/>
+            <a:cxnLst/>
+            <a:rect l="l" t="t" r="r" b="b"/>
+            <a:pathLst>
+              <a:path w="120000" h="120000" extrusionOk="0">
+                <a:moveTo>
+                  <a:pt x="0" y="0"/>
+                </a:moveTo>
+                <a:lnTo>
+                  <a:pt x="120000" y="0"/>
+                </a:lnTo>
+                <a:lnTo>
+                  <a:pt x="120000" y="120000"/>
+                </a:lnTo>
+                <a:lnTo>
+                  <a:pt x="0" y="120000"/>
+                </a:lnTo>
+                <a:close/>
+              </a:path>
+            </a:pathLst>
+          </a:custGeom>
+        </p:spPr>
+      </p:sp>
+      <p:sp>
+        <p:nvSpPr>
+          <p:cNvPr id="342" name="Google Shape;342;gd431007ba2_0_215:notes"/>
+          <p:cNvSpPr txBox="1">
+            <a:spLocks noGrp="1"/>
+          </p:cNvSpPr>
+          <p:nvPr>
+            <p:ph type="body" idx="1"/>
+          </p:nvPr>
+        </p:nvSpPr>
+        <p:spPr>
+          <a:xfrm>
+            <a:off x="685800" y="4343400"/>
+            <a:ext cx="5486400" cy="4114800"/>
+          </a:xfrm>
+          <a:prstGeom prst="rect">
+            <a:avLst/>
+          </a:prstGeom>
+        </p:spPr>
+        <p:txBody>
+          <a:bodyPr spcFirstLastPara="1" wrap="square" lIns="91425" tIns="91425" rIns="91425" bIns="91425" anchor="t" anchorCtr="0">
+            <a:noAutofit/>
+          </a:bodyPr>
+          <a:lstStyle/>
+          <a:p>
+            <a:pPr marL="0" lvl="0" indent="0" algn="l" rtl="0">
+              <a:spcBef>
+                <a:spcPts val="0"/>
+              </a:spcBef>
+              <a:spcAft>
+                <a:spcPts val="0"/>
+              </a:spcAft>
+              <a:buClr>
+                <a:schemeClr val="dk1"/>
+              </a:buClr>
+              <a:buSzPts val="1100"/>
+              <a:buFont typeface="Arial"/>
+              <a:buNone/>
+            </a:pPr>
+            <a:endParaRPr sz="1200" i="1">
+              <a:solidFill>
+                <a:srgbClr val="595959"/>
+              </a:solidFill>
+              <a:latin typeface="Anaheim"/>
+              <a:ea typeface="Anaheim"/>
+              <a:cs typeface="Anaheim"/>
+              <a:sym typeface="Anaheim"/>
+            </a:endParaRPr>
+          </a:p>
+          <a:p>
+            <a:pPr marL="0" lvl="0" indent="0" algn="l" rtl="0">
+              <a:spcBef>
+                <a:spcPts val="0"/>
+              </a:spcBef>
+              <a:spcAft>
+                <a:spcPts val="0"/>
+              </a:spcAft>
+              <a:buNone/>
+            </a:pPr>
+            <a:endParaRPr/>
+          </a:p>
+        </p:txBody>
+      </p:sp>
+    </p:spTree>
+  </p:cSld>
+  <p:clrMapOvr>
+    <a:masterClrMapping/>
+  </p:clrMapOvr>
+</p:notes>
+</file>
+
+<file path=ppt/notesSlides/notesSlide14.xml><?xml version="1.0" encoding="utf-8"?>
+<p:notes xmlns:a="http://schemas.openxmlformats.org/drawingml/2006/main" xmlns:r="http://schemas.openxmlformats.org/officeDocument/2006/relationships" xmlns:p="http://schemas.openxmlformats.org/presentationml/2006/main" showMasterSp="0" showMasterPhAnim="0">
+  <p:cSld>
+    <p:spTree>
+      <p:nvGrpSpPr>
         <p:cNvPr id="1" name="Shape 358">
           <a:extLst>
             <a:ext uri="{FF2B5EF4-FFF2-40B4-BE49-F238E27FC236}">
@@ -1444,7 +1586,7 @@
 </p:notes>
 </file>
 
-<file path=ppt/notesSlides/notesSlide14.xml><?xml version="1.0" encoding="utf-8"?>
+<file path=ppt/notesSlides/notesSlide15.xml><?xml version="1.0" encoding="utf-8"?>
 <p:notes xmlns:a="http://schemas.openxmlformats.org/drawingml/2006/main" xmlns:r="http://schemas.openxmlformats.org/officeDocument/2006/relationships" xmlns:p="http://schemas.openxmlformats.org/presentationml/2006/main" showMasterSp="0" showMasterPhAnim="0">
   <p:cSld>
     <p:spTree>
@@ -1578,7 +1720,7 @@
 </p:notes>
 </file>
 
-<file path=ppt/notesSlides/notesSlide15.xml><?xml version="1.0" encoding="utf-8"?>
+<file path=ppt/notesSlides/notesSlide16.xml><?xml version="1.0" encoding="utf-8"?>
 <p:notes xmlns:a="http://schemas.openxmlformats.org/drawingml/2006/main" xmlns:r="http://schemas.openxmlformats.org/officeDocument/2006/relationships" xmlns:p="http://schemas.openxmlformats.org/presentationml/2006/main" showMasterSp="0" showMasterPhAnim="0">
   <p:cSld>
     <p:spTree>
@@ -1712,7 +1854,7 @@
 </p:notes>
 </file>
 
-<file path=ppt/notesSlides/notesSlide16.xml><?xml version="1.0" encoding="utf-8"?>
+<file path=ppt/notesSlides/notesSlide17.xml><?xml version="1.0" encoding="utf-8"?>
 <p:notes xmlns:a="http://schemas.openxmlformats.org/drawingml/2006/main" xmlns:r="http://schemas.openxmlformats.org/officeDocument/2006/relationships" xmlns:p="http://schemas.openxmlformats.org/presentationml/2006/main" showMasterSp="0" showMasterPhAnim="0">
   <p:cSld>
     <p:spTree>
@@ -5694,6 +5836,2099 @@
 </p:sldLayout>
 </file>
 
+<file path=ppt/slideLayouts/slideLayout13.xml><?xml version="1.0" encoding="utf-8"?>
+<p:sldLayout xmlns:a="http://schemas.openxmlformats.org/drawingml/2006/main" xmlns:r="http://schemas.openxmlformats.org/officeDocument/2006/relationships" xmlns:p="http://schemas.openxmlformats.org/presentationml/2006/main" matchingName="Table of contents">
+  <p:cSld name="Table of contents">
+    <p:spTree>
+      <p:nvGrpSpPr>
+        <p:cNvPr id="1" name="Shape 103"/>
+        <p:cNvGrpSpPr/>
+        <p:nvPr/>
+      </p:nvGrpSpPr>
+      <p:grpSpPr>
+        <a:xfrm>
+          <a:off x="0" y="0"/>
+          <a:ext cx="0" cy="0"/>
+          <a:chOff x="0" y="0"/>
+          <a:chExt cx="0" cy="0"/>
+        </a:xfrm>
+      </p:grpSpPr>
+      <p:pic>
+        <p:nvPicPr>
+          <p:cNvPr id="104" name="Google Shape;104;p13"/>
+          <p:cNvPicPr preferRelativeResize="0"/>
+          <p:nvPr/>
+        </p:nvPicPr>
+        <p:blipFill>
+          <a:blip r:embed="rId2">
+            <a:alphaModFix/>
+          </a:blip>
+          <a:stretch>
+            <a:fillRect/>
+          </a:stretch>
+        </p:blipFill>
+        <p:spPr>
+          <a:xfrm>
+            <a:off x="-25" y="0"/>
+            <a:ext cx="9144000" cy="5143500"/>
+          </a:xfrm>
+          <a:prstGeom prst="rect">
+            <a:avLst/>
+          </a:prstGeom>
+          <a:noFill/>
+          <a:ln>
+            <a:noFill/>
+          </a:ln>
+        </p:spPr>
+      </p:pic>
+      <p:sp>
+        <p:nvSpPr>
+          <p:cNvPr id="105" name="Google Shape;105;p13"/>
+          <p:cNvSpPr txBox="1">
+            <a:spLocks noGrp="1"/>
+          </p:cNvSpPr>
+          <p:nvPr>
+            <p:ph type="title"/>
+          </p:nvPr>
+        </p:nvSpPr>
+        <p:spPr>
+          <a:xfrm>
+            <a:off x="720000" y="539500"/>
+            <a:ext cx="7704000" cy="572700"/>
+          </a:xfrm>
+          <a:prstGeom prst="rect">
+            <a:avLst/>
+          </a:prstGeom>
+        </p:spPr>
+        <p:txBody>
+          <a:bodyPr spcFirstLastPara="1" wrap="square" lIns="91425" tIns="91425" rIns="91425" bIns="91425" anchor="t" anchorCtr="0">
+            <a:noAutofit/>
+          </a:bodyPr>
+          <a:lstStyle>
+            <a:lvl1pPr lvl="0" algn="ctr" rtl="0">
+              <a:spcBef>
+                <a:spcPts val="0"/>
+              </a:spcBef>
+              <a:spcAft>
+                <a:spcPts val="0"/>
+              </a:spcAft>
+              <a:buSzPts val="3000"/>
+              <a:buNone/>
+              <a:defRPr/>
+            </a:lvl1pPr>
+            <a:lvl2pPr lvl="1" rtl="0">
+              <a:spcBef>
+                <a:spcPts val="0"/>
+              </a:spcBef>
+              <a:spcAft>
+                <a:spcPts val="0"/>
+              </a:spcAft>
+              <a:buSzPts val="3000"/>
+              <a:buNone/>
+              <a:defRPr/>
+            </a:lvl2pPr>
+            <a:lvl3pPr lvl="2" rtl="0">
+              <a:spcBef>
+                <a:spcPts val="0"/>
+              </a:spcBef>
+              <a:spcAft>
+                <a:spcPts val="0"/>
+              </a:spcAft>
+              <a:buSzPts val="3000"/>
+              <a:buNone/>
+              <a:defRPr/>
+            </a:lvl3pPr>
+            <a:lvl4pPr lvl="3" rtl="0">
+              <a:spcBef>
+                <a:spcPts val="0"/>
+              </a:spcBef>
+              <a:spcAft>
+                <a:spcPts val="0"/>
+              </a:spcAft>
+              <a:buSzPts val="3000"/>
+              <a:buNone/>
+              <a:defRPr/>
+            </a:lvl4pPr>
+            <a:lvl5pPr lvl="4" rtl="0">
+              <a:spcBef>
+                <a:spcPts val="0"/>
+              </a:spcBef>
+              <a:spcAft>
+                <a:spcPts val="0"/>
+              </a:spcAft>
+              <a:buSzPts val="3000"/>
+              <a:buNone/>
+              <a:defRPr/>
+            </a:lvl5pPr>
+            <a:lvl6pPr lvl="5" rtl="0">
+              <a:spcBef>
+                <a:spcPts val="0"/>
+              </a:spcBef>
+              <a:spcAft>
+                <a:spcPts val="0"/>
+              </a:spcAft>
+              <a:buSzPts val="3000"/>
+              <a:buNone/>
+              <a:defRPr/>
+            </a:lvl6pPr>
+            <a:lvl7pPr lvl="6" rtl="0">
+              <a:spcBef>
+                <a:spcPts val="0"/>
+              </a:spcBef>
+              <a:spcAft>
+                <a:spcPts val="0"/>
+              </a:spcAft>
+              <a:buSzPts val="3000"/>
+              <a:buNone/>
+              <a:defRPr/>
+            </a:lvl7pPr>
+            <a:lvl8pPr lvl="7" rtl="0">
+              <a:spcBef>
+                <a:spcPts val="0"/>
+              </a:spcBef>
+              <a:spcAft>
+                <a:spcPts val="0"/>
+              </a:spcAft>
+              <a:buSzPts val="3000"/>
+              <a:buNone/>
+              <a:defRPr/>
+            </a:lvl8pPr>
+            <a:lvl9pPr lvl="8" rtl="0">
+              <a:spcBef>
+                <a:spcPts val="0"/>
+              </a:spcBef>
+              <a:spcAft>
+                <a:spcPts val="0"/>
+              </a:spcAft>
+              <a:buSzPts val="3000"/>
+              <a:buNone/>
+              <a:defRPr/>
+            </a:lvl9pPr>
+          </a:lstStyle>
+          <a:p>
+            <a:endParaRPr/>
+          </a:p>
+        </p:txBody>
+      </p:sp>
+      <p:sp>
+        <p:nvSpPr>
+          <p:cNvPr id="106" name="Google Shape;106;p13"/>
+          <p:cNvSpPr txBox="1">
+            <a:spLocks noGrp="1"/>
+          </p:cNvSpPr>
+          <p:nvPr>
+            <p:ph type="title" idx="2" hasCustomPrompt="1"/>
+          </p:nvPr>
+        </p:nvSpPr>
+        <p:spPr>
+          <a:xfrm>
+            <a:off x="3759205" y="1699096"/>
+            <a:ext cx="694800" cy="694800"/>
+          </a:xfrm>
+          <a:prstGeom prst="rect">
+            <a:avLst/>
+          </a:prstGeom>
+          <a:solidFill>
+            <a:schemeClr val="lt2"/>
+          </a:solidFill>
+        </p:spPr>
+        <p:txBody>
+          <a:bodyPr spcFirstLastPara="1" wrap="square" lIns="91425" tIns="91425" rIns="91425" bIns="91425" anchor="ctr" anchorCtr="0">
+            <a:noAutofit/>
+          </a:bodyPr>
+          <a:lstStyle>
+            <a:lvl1pPr lvl="0" algn="ctr" rtl="0">
+              <a:spcBef>
+                <a:spcPts val="0"/>
+              </a:spcBef>
+              <a:spcAft>
+                <a:spcPts val="0"/>
+              </a:spcAft>
+              <a:buSzPts val="3000"/>
+              <a:buNone/>
+              <a:defRPr sz="3000"/>
+            </a:lvl1pPr>
+            <a:lvl2pPr lvl="1" rtl="0">
+              <a:spcBef>
+                <a:spcPts val="0"/>
+              </a:spcBef>
+              <a:spcAft>
+                <a:spcPts val="0"/>
+              </a:spcAft>
+              <a:buSzPts val="3000"/>
+              <a:buNone/>
+              <a:defRPr sz="3000"/>
+            </a:lvl2pPr>
+            <a:lvl3pPr lvl="2" rtl="0">
+              <a:spcBef>
+                <a:spcPts val="0"/>
+              </a:spcBef>
+              <a:spcAft>
+                <a:spcPts val="0"/>
+              </a:spcAft>
+              <a:buSzPts val="3000"/>
+              <a:buNone/>
+              <a:defRPr sz="3000"/>
+            </a:lvl3pPr>
+            <a:lvl4pPr lvl="3" rtl="0">
+              <a:spcBef>
+                <a:spcPts val="0"/>
+              </a:spcBef>
+              <a:spcAft>
+                <a:spcPts val="0"/>
+              </a:spcAft>
+              <a:buSzPts val="3000"/>
+              <a:buNone/>
+              <a:defRPr sz="3000"/>
+            </a:lvl4pPr>
+            <a:lvl5pPr lvl="4" rtl="0">
+              <a:spcBef>
+                <a:spcPts val="0"/>
+              </a:spcBef>
+              <a:spcAft>
+                <a:spcPts val="0"/>
+              </a:spcAft>
+              <a:buSzPts val="3000"/>
+              <a:buNone/>
+              <a:defRPr sz="3000"/>
+            </a:lvl5pPr>
+            <a:lvl6pPr lvl="5" rtl="0">
+              <a:spcBef>
+                <a:spcPts val="0"/>
+              </a:spcBef>
+              <a:spcAft>
+                <a:spcPts val="0"/>
+              </a:spcAft>
+              <a:buSzPts val="3000"/>
+              <a:buNone/>
+              <a:defRPr sz="3000"/>
+            </a:lvl6pPr>
+            <a:lvl7pPr lvl="6" rtl="0">
+              <a:spcBef>
+                <a:spcPts val="0"/>
+              </a:spcBef>
+              <a:spcAft>
+                <a:spcPts val="0"/>
+              </a:spcAft>
+              <a:buSzPts val="3000"/>
+              <a:buNone/>
+              <a:defRPr sz="3000"/>
+            </a:lvl7pPr>
+            <a:lvl8pPr lvl="7" rtl="0">
+              <a:spcBef>
+                <a:spcPts val="0"/>
+              </a:spcBef>
+              <a:spcAft>
+                <a:spcPts val="0"/>
+              </a:spcAft>
+              <a:buSzPts val="3000"/>
+              <a:buNone/>
+              <a:defRPr sz="3000"/>
+            </a:lvl8pPr>
+            <a:lvl9pPr lvl="8" rtl="0">
+              <a:spcBef>
+                <a:spcPts val="0"/>
+              </a:spcBef>
+              <a:spcAft>
+                <a:spcPts val="0"/>
+              </a:spcAft>
+              <a:buSzPts val="3000"/>
+              <a:buNone/>
+              <a:defRPr sz="3000"/>
+            </a:lvl9pPr>
+          </a:lstStyle>
+          <a:p>
+            <a:r>
+              <a:t>xx%</a:t>
+            </a:r>
+          </a:p>
+        </p:txBody>
+      </p:sp>
+      <p:sp>
+        <p:nvSpPr>
+          <p:cNvPr id="107" name="Google Shape;107;p13"/>
+          <p:cNvSpPr txBox="1">
+            <a:spLocks noGrp="1"/>
+          </p:cNvSpPr>
+          <p:nvPr>
+            <p:ph type="title" idx="3" hasCustomPrompt="1"/>
+          </p:nvPr>
+        </p:nvSpPr>
+        <p:spPr>
+          <a:xfrm>
+            <a:off x="4690005" y="1699096"/>
+            <a:ext cx="694800" cy="694800"/>
+          </a:xfrm>
+          <a:prstGeom prst="rect">
+            <a:avLst/>
+          </a:prstGeom>
+          <a:solidFill>
+            <a:schemeClr val="lt2"/>
+          </a:solidFill>
+        </p:spPr>
+        <p:txBody>
+          <a:bodyPr spcFirstLastPara="1" wrap="square" lIns="91425" tIns="91425" rIns="91425" bIns="91425" anchor="ctr" anchorCtr="0">
+            <a:noAutofit/>
+          </a:bodyPr>
+          <a:lstStyle>
+            <a:lvl1pPr lvl="0" algn="ctr" rtl="0">
+              <a:spcBef>
+                <a:spcPts val="0"/>
+              </a:spcBef>
+              <a:spcAft>
+                <a:spcPts val="0"/>
+              </a:spcAft>
+              <a:buSzPts val="3000"/>
+              <a:buNone/>
+              <a:defRPr sz="3000"/>
+            </a:lvl1pPr>
+            <a:lvl2pPr lvl="1" rtl="0">
+              <a:spcBef>
+                <a:spcPts val="0"/>
+              </a:spcBef>
+              <a:spcAft>
+                <a:spcPts val="0"/>
+              </a:spcAft>
+              <a:buSzPts val="3000"/>
+              <a:buNone/>
+              <a:defRPr sz="3000"/>
+            </a:lvl2pPr>
+            <a:lvl3pPr lvl="2" rtl="0">
+              <a:spcBef>
+                <a:spcPts val="0"/>
+              </a:spcBef>
+              <a:spcAft>
+                <a:spcPts val="0"/>
+              </a:spcAft>
+              <a:buSzPts val="3000"/>
+              <a:buNone/>
+              <a:defRPr sz="3000"/>
+            </a:lvl3pPr>
+            <a:lvl4pPr lvl="3" rtl="0">
+              <a:spcBef>
+                <a:spcPts val="0"/>
+              </a:spcBef>
+              <a:spcAft>
+                <a:spcPts val="0"/>
+              </a:spcAft>
+              <a:buSzPts val="3000"/>
+              <a:buNone/>
+              <a:defRPr sz="3000"/>
+            </a:lvl4pPr>
+            <a:lvl5pPr lvl="4" rtl="0">
+              <a:spcBef>
+                <a:spcPts val="0"/>
+              </a:spcBef>
+              <a:spcAft>
+                <a:spcPts val="0"/>
+              </a:spcAft>
+              <a:buSzPts val="3000"/>
+              <a:buNone/>
+              <a:defRPr sz="3000"/>
+            </a:lvl5pPr>
+            <a:lvl6pPr lvl="5" rtl="0">
+              <a:spcBef>
+                <a:spcPts val="0"/>
+              </a:spcBef>
+              <a:spcAft>
+                <a:spcPts val="0"/>
+              </a:spcAft>
+              <a:buSzPts val="3000"/>
+              <a:buNone/>
+              <a:defRPr sz="3000"/>
+            </a:lvl6pPr>
+            <a:lvl7pPr lvl="6" rtl="0">
+              <a:spcBef>
+                <a:spcPts val="0"/>
+              </a:spcBef>
+              <a:spcAft>
+                <a:spcPts val="0"/>
+              </a:spcAft>
+              <a:buSzPts val="3000"/>
+              <a:buNone/>
+              <a:defRPr sz="3000"/>
+            </a:lvl7pPr>
+            <a:lvl8pPr lvl="7" rtl="0">
+              <a:spcBef>
+                <a:spcPts val="0"/>
+              </a:spcBef>
+              <a:spcAft>
+                <a:spcPts val="0"/>
+              </a:spcAft>
+              <a:buSzPts val="3000"/>
+              <a:buNone/>
+              <a:defRPr sz="3000"/>
+            </a:lvl8pPr>
+            <a:lvl9pPr lvl="8" rtl="0">
+              <a:spcBef>
+                <a:spcPts val="0"/>
+              </a:spcBef>
+              <a:spcAft>
+                <a:spcPts val="0"/>
+              </a:spcAft>
+              <a:buSzPts val="3000"/>
+              <a:buNone/>
+              <a:defRPr sz="3000"/>
+            </a:lvl9pPr>
+          </a:lstStyle>
+          <a:p>
+            <a:r>
+              <a:t>xx%</a:t>
+            </a:r>
+          </a:p>
+        </p:txBody>
+      </p:sp>
+      <p:sp>
+        <p:nvSpPr>
+          <p:cNvPr id="108" name="Google Shape;108;p13"/>
+          <p:cNvSpPr txBox="1">
+            <a:spLocks noGrp="1"/>
+          </p:cNvSpPr>
+          <p:nvPr>
+            <p:ph type="title" idx="4" hasCustomPrompt="1"/>
+          </p:nvPr>
+        </p:nvSpPr>
+        <p:spPr>
+          <a:xfrm>
+            <a:off x="3759193" y="2781754"/>
+            <a:ext cx="694800" cy="694800"/>
+          </a:xfrm>
+          <a:prstGeom prst="rect">
+            <a:avLst/>
+          </a:prstGeom>
+          <a:solidFill>
+            <a:schemeClr val="lt2"/>
+          </a:solidFill>
+        </p:spPr>
+        <p:txBody>
+          <a:bodyPr spcFirstLastPara="1" wrap="square" lIns="91425" tIns="91425" rIns="91425" bIns="91425" anchor="ctr" anchorCtr="0">
+            <a:noAutofit/>
+          </a:bodyPr>
+          <a:lstStyle>
+            <a:lvl1pPr lvl="0" algn="ctr" rtl="0">
+              <a:spcBef>
+                <a:spcPts val="0"/>
+              </a:spcBef>
+              <a:spcAft>
+                <a:spcPts val="0"/>
+              </a:spcAft>
+              <a:buSzPts val="3000"/>
+              <a:buNone/>
+              <a:defRPr sz="3000"/>
+            </a:lvl1pPr>
+            <a:lvl2pPr lvl="1" rtl="0">
+              <a:spcBef>
+                <a:spcPts val="0"/>
+              </a:spcBef>
+              <a:spcAft>
+                <a:spcPts val="0"/>
+              </a:spcAft>
+              <a:buSzPts val="3000"/>
+              <a:buNone/>
+              <a:defRPr sz="3000"/>
+            </a:lvl2pPr>
+            <a:lvl3pPr lvl="2" rtl="0">
+              <a:spcBef>
+                <a:spcPts val="0"/>
+              </a:spcBef>
+              <a:spcAft>
+                <a:spcPts val="0"/>
+              </a:spcAft>
+              <a:buSzPts val="3000"/>
+              <a:buNone/>
+              <a:defRPr sz="3000"/>
+            </a:lvl3pPr>
+            <a:lvl4pPr lvl="3" rtl="0">
+              <a:spcBef>
+                <a:spcPts val="0"/>
+              </a:spcBef>
+              <a:spcAft>
+                <a:spcPts val="0"/>
+              </a:spcAft>
+              <a:buSzPts val="3000"/>
+              <a:buNone/>
+              <a:defRPr sz="3000"/>
+            </a:lvl4pPr>
+            <a:lvl5pPr lvl="4" rtl="0">
+              <a:spcBef>
+                <a:spcPts val="0"/>
+              </a:spcBef>
+              <a:spcAft>
+                <a:spcPts val="0"/>
+              </a:spcAft>
+              <a:buSzPts val="3000"/>
+              <a:buNone/>
+              <a:defRPr sz="3000"/>
+            </a:lvl5pPr>
+            <a:lvl6pPr lvl="5" rtl="0">
+              <a:spcBef>
+                <a:spcPts val="0"/>
+              </a:spcBef>
+              <a:spcAft>
+                <a:spcPts val="0"/>
+              </a:spcAft>
+              <a:buSzPts val="3000"/>
+              <a:buNone/>
+              <a:defRPr sz="3000"/>
+            </a:lvl6pPr>
+            <a:lvl7pPr lvl="6" rtl="0">
+              <a:spcBef>
+                <a:spcPts val="0"/>
+              </a:spcBef>
+              <a:spcAft>
+                <a:spcPts val="0"/>
+              </a:spcAft>
+              <a:buSzPts val="3000"/>
+              <a:buNone/>
+              <a:defRPr sz="3000"/>
+            </a:lvl7pPr>
+            <a:lvl8pPr lvl="7" rtl="0">
+              <a:spcBef>
+                <a:spcPts val="0"/>
+              </a:spcBef>
+              <a:spcAft>
+                <a:spcPts val="0"/>
+              </a:spcAft>
+              <a:buSzPts val="3000"/>
+              <a:buNone/>
+              <a:defRPr sz="3000"/>
+            </a:lvl8pPr>
+            <a:lvl9pPr lvl="8" rtl="0">
+              <a:spcBef>
+                <a:spcPts val="0"/>
+              </a:spcBef>
+              <a:spcAft>
+                <a:spcPts val="0"/>
+              </a:spcAft>
+              <a:buSzPts val="3000"/>
+              <a:buNone/>
+              <a:defRPr sz="3000"/>
+            </a:lvl9pPr>
+          </a:lstStyle>
+          <a:p>
+            <a:r>
+              <a:t>xx%</a:t>
+            </a:r>
+          </a:p>
+        </p:txBody>
+      </p:sp>
+      <p:sp>
+        <p:nvSpPr>
+          <p:cNvPr id="109" name="Google Shape;109;p13"/>
+          <p:cNvSpPr txBox="1">
+            <a:spLocks noGrp="1"/>
+          </p:cNvSpPr>
+          <p:nvPr>
+            <p:ph type="title" idx="5" hasCustomPrompt="1"/>
+          </p:nvPr>
+        </p:nvSpPr>
+        <p:spPr>
+          <a:xfrm>
+            <a:off x="4689993" y="2781754"/>
+            <a:ext cx="694800" cy="694800"/>
+          </a:xfrm>
+          <a:prstGeom prst="rect">
+            <a:avLst/>
+          </a:prstGeom>
+          <a:solidFill>
+            <a:schemeClr val="lt2"/>
+          </a:solidFill>
+        </p:spPr>
+        <p:txBody>
+          <a:bodyPr spcFirstLastPara="1" wrap="square" lIns="91425" tIns="91425" rIns="91425" bIns="91425" anchor="ctr" anchorCtr="0">
+            <a:noAutofit/>
+          </a:bodyPr>
+          <a:lstStyle>
+            <a:lvl1pPr lvl="0" algn="ctr" rtl="0">
+              <a:spcBef>
+                <a:spcPts val="0"/>
+              </a:spcBef>
+              <a:spcAft>
+                <a:spcPts val="0"/>
+              </a:spcAft>
+              <a:buSzPts val="3000"/>
+              <a:buNone/>
+              <a:defRPr sz="3000"/>
+            </a:lvl1pPr>
+            <a:lvl2pPr lvl="1" rtl="0">
+              <a:spcBef>
+                <a:spcPts val="0"/>
+              </a:spcBef>
+              <a:spcAft>
+                <a:spcPts val="0"/>
+              </a:spcAft>
+              <a:buSzPts val="3000"/>
+              <a:buNone/>
+              <a:defRPr sz="3000"/>
+            </a:lvl2pPr>
+            <a:lvl3pPr lvl="2" rtl="0">
+              <a:spcBef>
+                <a:spcPts val="0"/>
+              </a:spcBef>
+              <a:spcAft>
+                <a:spcPts val="0"/>
+              </a:spcAft>
+              <a:buSzPts val="3000"/>
+              <a:buNone/>
+              <a:defRPr sz="3000"/>
+            </a:lvl3pPr>
+            <a:lvl4pPr lvl="3" rtl="0">
+              <a:spcBef>
+                <a:spcPts val="0"/>
+              </a:spcBef>
+              <a:spcAft>
+                <a:spcPts val="0"/>
+              </a:spcAft>
+              <a:buSzPts val="3000"/>
+              <a:buNone/>
+              <a:defRPr sz="3000"/>
+            </a:lvl4pPr>
+            <a:lvl5pPr lvl="4" rtl="0">
+              <a:spcBef>
+                <a:spcPts val="0"/>
+              </a:spcBef>
+              <a:spcAft>
+                <a:spcPts val="0"/>
+              </a:spcAft>
+              <a:buSzPts val="3000"/>
+              <a:buNone/>
+              <a:defRPr sz="3000"/>
+            </a:lvl5pPr>
+            <a:lvl6pPr lvl="5" rtl="0">
+              <a:spcBef>
+                <a:spcPts val="0"/>
+              </a:spcBef>
+              <a:spcAft>
+                <a:spcPts val="0"/>
+              </a:spcAft>
+              <a:buSzPts val="3000"/>
+              <a:buNone/>
+              <a:defRPr sz="3000"/>
+            </a:lvl6pPr>
+            <a:lvl7pPr lvl="6" rtl="0">
+              <a:spcBef>
+                <a:spcPts val="0"/>
+              </a:spcBef>
+              <a:spcAft>
+                <a:spcPts val="0"/>
+              </a:spcAft>
+              <a:buSzPts val="3000"/>
+              <a:buNone/>
+              <a:defRPr sz="3000"/>
+            </a:lvl7pPr>
+            <a:lvl8pPr lvl="7" rtl="0">
+              <a:spcBef>
+                <a:spcPts val="0"/>
+              </a:spcBef>
+              <a:spcAft>
+                <a:spcPts val="0"/>
+              </a:spcAft>
+              <a:buSzPts val="3000"/>
+              <a:buNone/>
+              <a:defRPr sz="3000"/>
+            </a:lvl8pPr>
+            <a:lvl9pPr lvl="8" rtl="0">
+              <a:spcBef>
+                <a:spcPts val="0"/>
+              </a:spcBef>
+              <a:spcAft>
+                <a:spcPts val="0"/>
+              </a:spcAft>
+              <a:buSzPts val="3000"/>
+              <a:buNone/>
+              <a:defRPr sz="3000"/>
+            </a:lvl9pPr>
+          </a:lstStyle>
+          <a:p>
+            <a:r>
+              <a:t>xx%</a:t>
+            </a:r>
+          </a:p>
+        </p:txBody>
+      </p:sp>
+      <p:sp>
+        <p:nvSpPr>
+          <p:cNvPr id="110" name="Google Shape;110;p13"/>
+          <p:cNvSpPr txBox="1">
+            <a:spLocks noGrp="1"/>
+          </p:cNvSpPr>
+          <p:nvPr>
+            <p:ph type="title" idx="6" hasCustomPrompt="1"/>
+          </p:nvPr>
+        </p:nvSpPr>
+        <p:spPr>
+          <a:xfrm>
+            <a:off x="3759207" y="3864413"/>
+            <a:ext cx="694800" cy="694800"/>
+          </a:xfrm>
+          <a:prstGeom prst="rect">
+            <a:avLst/>
+          </a:prstGeom>
+          <a:solidFill>
+            <a:schemeClr val="lt2"/>
+          </a:solidFill>
+        </p:spPr>
+        <p:txBody>
+          <a:bodyPr spcFirstLastPara="1" wrap="square" lIns="91425" tIns="91425" rIns="91425" bIns="91425" anchor="ctr" anchorCtr="0">
+            <a:noAutofit/>
+          </a:bodyPr>
+          <a:lstStyle>
+            <a:lvl1pPr lvl="0" algn="ctr" rtl="0">
+              <a:spcBef>
+                <a:spcPts val="0"/>
+              </a:spcBef>
+              <a:spcAft>
+                <a:spcPts val="0"/>
+              </a:spcAft>
+              <a:buSzPts val="3000"/>
+              <a:buNone/>
+              <a:defRPr sz="3000"/>
+            </a:lvl1pPr>
+            <a:lvl2pPr lvl="1" rtl="0">
+              <a:spcBef>
+                <a:spcPts val="0"/>
+              </a:spcBef>
+              <a:spcAft>
+                <a:spcPts val="0"/>
+              </a:spcAft>
+              <a:buSzPts val="3000"/>
+              <a:buNone/>
+              <a:defRPr sz="3000"/>
+            </a:lvl2pPr>
+            <a:lvl3pPr lvl="2" rtl="0">
+              <a:spcBef>
+                <a:spcPts val="0"/>
+              </a:spcBef>
+              <a:spcAft>
+                <a:spcPts val="0"/>
+              </a:spcAft>
+              <a:buSzPts val="3000"/>
+              <a:buNone/>
+              <a:defRPr sz="3000"/>
+            </a:lvl3pPr>
+            <a:lvl4pPr lvl="3" rtl="0">
+              <a:spcBef>
+                <a:spcPts val="0"/>
+              </a:spcBef>
+              <a:spcAft>
+                <a:spcPts val="0"/>
+              </a:spcAft>
+              <a:buSzPts val="3000"/>
+              <a:buNone/>
+              <a:defRPr sz="3000"/>
+            </a:lvl4pPr>
+            <a:lvl5pPr lvl="4" rtl="0">
+              <a:spcBef>
+                <a:spcPts val="0"/>
+              </a:spcBef>
+              <a:spcAft>
+                <a:spcPts val="0"/>
+              </a:spcAft>
+              <a:buSzPts val="3000"/>
+              <a:buNone/>
+              <a:defRPr sz="3000"/>
+            </a:lvl5pPr>
+            <a:lvl6pPr lvl="5" rtl="0">
+              <a:spcBef>
+                <a:spcPts val="0"/>
+              </a:spcBef>
+              <a:spcAft>
+                <a:spcPts val="0"/>
+              </a:spcAft>
+              <a:buSzPts val="3000"/>
+              <a:buNone/>
+              <a:defRPr sz="3000"/>
+            </a:lvl6pPr>
+            <a:lvl7pPr lvl="6" rtl="0">
+              <a:spcBef>
+                <a:spcPts val="0"/>
+              </a:spcBef>
+              <a:spcAft>
+                <a:spcPts val="0"/>
+              </a:spcAft>
+              <a:buSzPts val="3000"/>
+              <a:buNone/>
+              <a:defRPr sz="3000"/>
+            </a:lvl7pPr>
+            <a:lvl8pPr lvl="7" rtl="0">
+              <a:spcBef>
+                <a:spcPts val="0"/>
+              </a:spcBef>
+              <a:spcAft>
+                <a:spcPts val="0"/>
+              </a:spcAft>
+              <a:buSzPts val="3000"/>
+              <a:buNone/>
+              <a:defRPr sz="3000"/>
+            </a:lvl8pPr>
+            <a:lvl9pPr lvl="8" rtl="0">
+              <a:spcBef>
+                <a:spcPts val="0"/>
+              </a:spcBef>
+              <a:spcAft>
+                <a:spcPts val="0"/>
+              </a:spcAft>
+              <a:buSzPts val="3000"/>
+              <a:buNone/>
+              <a:defRPr sz="3000"/>
+            </a:lvl9pPr>
+          </a:lstStyle>
+          <a:p>
+            <a:r>
+              <a:t>xx%</a:t>
+            </a:r>
+          </a:p>
+        </p:txBody>
+      </p:sp>
+      <p:sp>
+        <p:nvSpPr>
+          <p:cNvPr id="111" name="Google Shape;111;p13"/>
+          <p:cNvSpPr txBox="1">
+            <a:spLocks noGrp="1"/>
+          </p:cNvSpPr>
+          <p:nvPr>
+            <p:ph type="title" idx="7" hasCustomPrompt="1"/>
+          </p:nvPr>
+        </p:nvSpPr>
+        <p:spPr>
+          <a:xfrm>
+            <a:off x="4690007" y="3864413"/>
+            <a:ext cx="694800" cy="694800"/>
+          </a:xfrm>
+          <a:prstGeom prst="rect">
+            <a:avLst/>
+          </a:prstGeom>
+          <a:solidFill>
+            <a:schemeClr val="lt2"/>
+          </a:solidFill>
+        </p:spPr>
+        <p:txBody>
+          <a:bodyPr spcFirstLastPara="1" wrap="square" lIns="91425" tIns="91425" rIns="91425" bIns="91425" anchor="ctr" anchorCtr="0">
+            <a:noAutofit/>
+          </a:bodyPr>
+          <a:lstStyle>
+            <a:lvl1pPr lvl="0" algn="ctr" rtl="0">
+              <a:spcBef>
+                <a:spcPts val="0"/>
+              </a:spcBef>
+              <a:spcAft>
+                <a:spcPts val="0"/>
+              </a:spcAft>
+              <a:buSzPts val="3000"/>
+              <a:buNone/>
+              <a:defRPr sz="3000"/>
+            </a:lvl1pPr>
+            <a:lvl2pPr lvl="1" rtl="0">
+              <a:spcBef>
+                <a:spcPts val="0"/>
+              </a:spcBef>
+              <a:spcAft>
+                <a:spcPts val="0"/>
+              </a:spcAft>
+              <a:buSzPts val="3000"/>
+              <a:buNone/>
+              <a:defRPr sz="3000"/>
+            </a:lvl2pPr>
+            <a:lvl3pPr lvl="2" rtl="0">
+              <a:spcBef>
+                <a:spcPts val="0"/>
+              </a:spcBef>
+              <a:spcAft>
+                <a:spcPts val="0"/>
+              </a:spcAft>
+              <a:buSzPts val="3000"/>
+              <a:buNone/>
+              <a:defRPr sz="3000"/>
+            </a:lvl3pPr>
+            <a:lvl4pPr lvl="3" rtl="0">
+              <a:spcBef>
+                <a:spcPts val="0"/>
+              </a:spcBef>
+              <a:spcAft>
+                <a:spcPts val="0"/>
+              </a:spcAft>
+              <a:buSzPts val="3000"/>
+              <a:buNone/>
+              <a:defRPr sz="3000"/>
+            </a:lvl4pPr>
+            <a:lvl5pPr lvl="4" rtl="0">
+              <a:spcBef>
+                <a:spcPts val="0"/>
+              </a:spcBef>
+              <a:spcAft>
+                <a:spcPts val="0"/>
+              </a:spcAft>
+              <a:buSzPts val="3000"/>
+              <a:buNone/>
+              <a:defRPr sz="3000"/>
+            </a:lvl5pPr>
+            <a:lvl6pPr lvl="5" rtl="0">
+              <a:spcBef>
+                <a:spcPts val="0"/>
+              </a:spcBef>
+              <a:spcAft>
+                <a:spcPts val="0"/>
+              </a:spcAft>
+              <a:buSzPts val="3000"/>
+              <a:buNone/>
+              <a:defRPr sz="3000"/>
+            </a:lvl6pPr>
+            <a:lvl7pPr lvl="6" rtl="0">
+              <a:spcBef>
+                <a:spcPts val="0"/>
+              </a:spcBef>
+              <a:spcAft>
+                <a:spcPts val="0"/>
+              </a:spcAft>
+              <a:buSzPts val="3000"/>
+              <a:buNone/>
+              <a:defRPr sz="3000"/>
+            </a:lvl7pPr>
+            <a:lvl8pPr lvl="7" rtl="0">
+              <a:spcBef>
+                <a:spcPts val="0"/>
+              </a:spcBef>
+              <a:spcAft>
+                <a:spcPts val="0"/>
+              </a:spcAft>
+              <a:buSzPts val="3000"/>
+              <a:buNone/>
+              <a:defRPr sz="3000"/>
+            </a:lvl8pPr>
+            <a:lvl9pPr lvl="8" rtl="0">
+              <a:spcBef>
+                <a:spcPts val="0"/>
+              </a:spcBef>
+              <a:spcAft>
+                <a:spcPts val="0"/>
+              </a:spcAft>
+              <a:buSzPts val="3000"/>
+              <a:buNone/>
+              <a:defRPr sz="3000"/>
+            </a:lvl9pPr>
+          </a:lstStyle>
+          <a:p>
+            <a:r>
+              <a:t>xx%</a:t>
+            </a:r>
+          </a:p>
+        </p:txBody>
+      </p:sp>
+      <p:sp>
+        <p:nvSpPr>
+          <p:cNvPr id="112" name="Google Shape;112;p13"/>
+          <p:cNvSpPr txBox="1">
+            <a:spLocks noGrp="1"/>
+          </p:cNvSpPr>
+          <p:nvPr>
+            <p:ph type="subTitle" idx="1"/>
+          </p:nvPr>
+        </p:nvSpPr>
+        <p:spPr>
+          <a:xfrm>
+            <a:off x="1280600" y="1699100"/>
+            <a:ext cx="2288100" cy="694800"/>
+          </a:xfrm>
+          <a:prstGeom prst="rect">
+            <a:avLst/>
+          </a:prstGeom>
+        </p:spPr>
+        <p:txBody>
+          <a:bodyPr spcFirstLastPara="1" wrap="square" lIns="91425" tIns="91425" rIns="91425" bIns="91425" anchor="ctr" anchorCtr="0">
+            <a:noAutofit/>
+          </a:bodyPr>
+          <a:lstStyle>
+            <a:lvl1pPr lvl="0" algn="r" rtl="0">
+              <a:lnSpc>
+                <a:spcPct val="100000"/>
+              </a:lnSpc>
+              <a:spcBef>
+                <a:spcPts val="0"/>
+              </a:spcBef>
+              <a:spcAft>
+                <a:spcPts val="0"/>
+              </a:spcAft>
+              <a:buSzPts val="2400"/>
+              <a:buNone/>
+              <a:defRPr sz="1800" b="1">
+                <a:solidFill>
+                  <a:schemeClr val="dk1"/>
+                </a:solidFill>
+              </a:defRPr>
+            </a:lvl1pPr>
+            <a:lvl2pPr lvl="1" rtl="0">
+              <a:lnSpc>
+                <a:spcPct val="100000"/>
+              </a:lnSpc>
+              <a:spcBef>
+                <a:spcPts val="0"/>
+              </a:spcBef>
+              <a:spcAft>
+                <a:spcPts val="0"/>
+              </a:spcAft>
+              <a:buSzPts val="2400"/>
+              <a:buNone/>
+              <a:defRPr sz="2400" b="1"/>
+            </a:lvl2pPr>
+            <a:lvl3pPr lvl="2" rtl="0">
+              <a:lnSpc>
+                <a:spcPct val="100000"/>
+              </a:lnSpc>
+              <a:spcBef>
+                <a:spcPts val="0"/>
+              </a:spcBef>
+              <a:spcAft>
+                <a:spcPts val="0"/>
+              </a:spcAft>
+              <a:buSzPts val="2400"/>
+              <a:buNone/>
+              <a:defRPr sz="2400" b="1"/>
+            </a:lvl3pPr>
+            <a:lvl4pPr lvl="3" rtl="0">
+              <a:lnSpc>
+                <a:spcPct val="100000"/>
+              </a:lnSpc>
+              <a:spcBef>
+                <a:spcPts val="0"/>
+              </a:spcBef>
+              <a:spcAft>
+                <a:spcPts val="0"/>
+              </a:spcAft>
+              <a:buSzPts val="2400"/>
+              <a:buNone/>
+              <a:defRPr sz="2400" b="1"/>
+            </a:lvl4pPr>
+            <a:lvl5pPr lvl="4" rtl="0">
+              <a:lnSpc>
+                <a:spcPct val="100000"/>
+              </a:lnSpc>
+              <a:spcBef>
+                <a:spcPts val="0"/>
+              </a:spcBef>
+              <a:spcAft>
+                <a:spcPts val="0"/>
+              </a:spcAft>
+              <a:buSzPts val="2400"/>
+              <a:buNone/>
+              <a:defRPr sz="2400" b="1"/>
+            </a:lvl5pPr>
+            <a:lvl6pPr lvl="5" rtl="0">
+              <a:lnSpc>
+                <a:spcPct val="100000"/>
+              </a:lnSpc>
+              <a:spcBef>
+                <a:spcPts val="0"/>
+              </a:spcBef>
+              <a:spcAft>
+                <a:spcPts val="0"/>
+              </a:spcAft>
+              <a:buSzPts val="2400"/>
+              <a:buNone/>
+              <a:defRPr sz="2400" b="1"/>
+            </a:lvl6pPr>
+            <a:lvl7pPr lvl="6" rtl="0">
+              <a:lnSpc>
+                <a:spcPct val="100000"/>
+              </a:lnSpc>
+              <a:spcBef>
+                <a:spcPts val="0"/>
+              </a:spcBef>
+              <a:spcAft>
+                <a:spcPts val="0"/>
+              </a:spcAft>
+              <a:buSzPts val="2400"/>
+              <a:buNone/>
+              <a:defRPr sz="2400" b="1"/>
+            </a:lvl7pPr>
+            <a:lvl8pPr lvl="7" rtl="0">
+              <a:lnSpc>
+                <a:spcPct val="100000"/>
+              </a:lnSpc>
+              <a:spcBef>
+                <a:spcPts val="0"/>
+              </a:spcBef>
+              <a:spcAft>
+                <a:spcPts val="0"/>
+              </a:spcAft>
+              <a:buSzPts val="2400"/>
+              <a:buNone/>
+              <a:defRPr sz="2400" b="1"/>
+            </a:lvl8pPr>
+            <a:lvl9pPr lvl="8" rtl="0">
+              <a:lnSpc>
+                <a:spcPct val="100000"/>
+              </a:lnSpc>
+              <a:spcBef>
+                <a:spcPts val="0"/>
+              </a:spcBef>
+              <a:spcAft>
+                <a:spcPts val="0"/>
+              </a:spcAft>
+              <a:buSzPts val="2400"/>
+              <a:buNone/>
+              <a:defRPr sz="2400" b="1"/>
+            </a:lvl9pPr>
+          </a:lstStyle>
+          <a:p>
+            <a:endParaRPr/>
+          </a:p>
+        </p:txBody>
+      </p:sp>
+      <p:sp>
+        <p:nvSpPr>
+          <p:cNvPr id="113" name="Google Shape;113;p13"/>
+          <p:cNvSpPr txBox="1">
+            <a:spLocks noGrp="1"/>
+          </p:cNvSpPr>
+          <p:nvPr>
+            <p:ph type="subTitle" idx="8"/>
+          </p:nvPr>
+        </p:nvSpPr>
+        <p:spPr>
+          <a:xfrm>
+            <a:off x="1280600" y="2781762"/>
+            <a:ext cx="2288100" cy="694800"/>
+          </a:xfrm>
+          <a:prstGeom prst="rect">
+            <a:avLst/>
+          </a:prstGeom>
+        </p:spPr>
+        <p:txBody>
+          <a:bodyPr spcFirstLastPara="1" wrap="square" lIns="91425" tIns="91425" rIns="91425" bIns="91425" anchor="ctr" anchorCtr="0">
+            <a:noAutofit/>
+          </a:bodyPr>
+          <a:lstStyle>
+            <a:lvl1pPr lvl="0" algn="r" rtl="0">
+              <a:lnSpc>
+                <a:spcPct val="100000"/>
+              </a:lnSpc>
+              <a:spcBef>
+                <a:spcPts val="0"/>
+              </a:spcBef>
+              <a:spcAft>
+                <a:spcPts val="0"/>
+              </a:spcAft>
+              <a:buSzPts val="2400"/>
+              <a:buNone/>
+              <a:defRPr sz="1800" b="1">
+                <a:solidFill>
+                  <a:schemeClr val="dk1"/>
+                </a:solidFill>
+              </a:defRPr>
+            </a:lvl1pPr>
+            <a:lvl2pPr lvl="1" rtl="0">
+              <a:lnSpc>
+                <a:spcPct val="100000"/>
+              </a:lnSpc>
+              <a:spcBef>
+                <a:spcPts val="0"/>
+              </a:spcBef>
+              <a:spcAft>
+                <a:spcPts val="0"/>
+              </a:spcAft>
+              <a:buSzPts val="2400"/>
+              <a:buNone/>
+              <a:defRPr sz="2400" b="1"/>
+            </a:lvl2pPr>
+            <a:lvl3pPr lvl="2" rtl="0">
+              <a:lnSpc>
+                <a:spcPct val="100000"/>
+              </a:lnSpc>
+              <a:spcBef>
+                <a:spcPts val="0"/>
+              </a:spcBef>
+              <a:spcAft>
+                <a:spcPts val="0"/>
+              </a:spcAft>
+              <a:buSzPts val="2400"/>
+              <a:buNone/>
+              <a:defRPr sz="2400" b="1"/>
+            </a:lvl3pPr>
+            <a:lvl4pPr lvl="3" rtl="0">
+              <a:lnSpc>
+                <a:spcPct val="100000"/>
+              </a:lnSpc>
+              <a:spcBef>
+                <a:spcPts val="0"/>
+              </a:spcBef>
+              <a:spcAft>
+                <a:spcPts val="0"/>
+              </a:spcAft>
+              <a:buSzPts val="2400"/>
+              <a:buNone/>
+              <a:defRPr sz="2400" b="1"/>
+            </a:lvl4pPr>
+            <a:lvl5pPr lvl="4" rtl="0">
+              <a:lnSpc>
+                <a:spcPct val="100000"/>
+              </a:lnSpc>
+              <a:spcBef>
+                <a:spcPts val="0"/>
+              </a:spcBef>
+              <a:spcAft>
+                <a:spcPts val="0"/>
+              </a:spcAft>
+              <a:buSzPts val="2400"/>
+              <a:buNone/>
+              <a:defRPr sz="2400" b="1"/>
+            </a:lvl5pPr>
+            <a:lvl6pPr lvl="5" rtl="0">
+              <a:lnSpc>
+                <a:spcPct val="100000"/>
+              </a:lnSpc>
+              <a:spcBef>
+                <a:spcPts val="0"/>
+              </a:spcBef>
+              <a:spcAft>
+                <a:spcPts val="0"/>
+              </a:spcAft>
+              <a:buSzPts val="2400"/>
+              <a:buNone/>
+              <a:defRPr sz="2400" b="1"/>
+            </a:lvl6pPr>
+            <a:lvl7pPr lvl="6" rtl="0">
+              <a:lnSpc>
+                <a:spcPct val="100000"/>
+              </a:lnSpc>
+              <a:spcBef>
+                <a:spcPts val="0"/>
+              </a:spcBef>
+              <a:spcAft>
+                <a:spcPts val="0"/>
+              </a:spcAft>
+              <a:buSzPts val="2400"/>
+              <a:buNone/>
+              <a:defRPr sz="2400" b="1"/>
+            </a:lvl7pPr>
+            <a:lvl8pPr lvl="7" rtl="0">
+              <a:lnSpc>
+                <a:spcPct val="100000"/>
+              </a:lnSpc>
+              <a:spcBef>
+                <a:spcPts val="0"/>
+              </a:spcBef>
+              <a:spcAft>
+                <a:spcPts val="0"/>
+              </a:spcAft>
+              <a:buSzPts val="2400"/>
+              <a:buNone/>
+              <a:defRPr sz="2400" b="1"/>
+            </a:lvl8pPr>
+            <a:lvl9pPr lvl="8" rtl="0">
+              <a:lnSpc>
+                <a:spcPct val="100000"/>
+              </a:lnSpc>
+              <a:spcBef>
+                <a:spcPts val="0"/>
+              </a:spcBef>
+              <a:spcAft>
+                <a:spcPts val="0"/>
+              </a:spcAft>
+              <a:buSzPts val="2400"/>
+              <a:buNone/>
+              <a:defRPr sz="2400" b="1"/>
+            </a:lvl9pPr>
+          </a:lstStyle>
+          <a:p>
+            <a:endParaRPr/>
+          </a:p>
+        </p:txBody>
+      </p:sp>
+      <p:sp>
+        <p:nvSpPr>
+          <p:cNvPr id="114" name="Google Shape;114;p13"/>
+          <p:cNvSpPr txBox="1">
+            <a:spLocks noGrp="1"/>
+          </p:cNvSpPr>
+          <p:nvPr>
+            <p:ph type="subTitle" idx="9"/>
+          </p:nvPr>
+        </p:nvSpPr>
+        <p:spPr>
+          <a:xfrm>
+            <a:off x="1280600" y="3864423"/>
+            <a:ext cx="2288100" cy="694800"/>
+          </a:xfrm>
+          <a:prstGeom prst="rect">
+            <a:avLst/>
+          </a:prstGeom>
+        </p:spPr>
+        <p:txBody>
+          <a:bodyPr spcFirstLastPara="1" wrap="square" lIns="91425" tIns="91425" rIns="91425" bIns="91425" anchor="ctr" anchorCtr="0">
+            <a:noAutofit/>
+          </a:bodyPr>
+          <a:lstStyle>
+            <a:lvl1pPr lvl="0" algn="r" rtl="0">
+              <a:lnSpc>
+                <a:spcPct val="100000"/>
+              </a:lnSpc>
+              <a:spcBef>
+                <a:spcPts val="0"/>
+              </a:spcBef>
+              <a:spcAft>
+                <a:spcPts val="0"/>
+              </a:spcAft>
+              <a:buSzPts val="2400"/>
+              <a:buNone/>
+              <a:defRPr sz="1800" b="1">
+                <a:solidFill>
+                  <a:schemeClr val="dk1"/>
+                </a:solidFill>
+              </a:defRPr>
+            </a:lvl1pPr>
+            <a:lvl2pPr lvl="1" rtl="0">
+              <a:lnSpc>
+                <a:spcPct val="100000"/>
+              </a:lnSpc>
+              <a:spcBef>
+                <a:spcPts val="0"/>
+              </a:spcBef>
+              <a:spcAft>
+                <a:spcPts val="0"/>
+              </a:spcAft>
+              <a:buSzPts val="2400"/>
+              <a:buNone/>
+              <a:defRPr sz="2400" b="1"/>
+            </a:lvl2pPr>
+            <a:lvl3pPr lvl="2" rtl="0">
+              <a:lnSpc>
+                <a:spcPct val="100000"/>
+              </a:lnSpc>
+              <a:spcBef>
+                <a:spcPts val="0"/>
+              </a:spcBef>
+              <a:spcAft>
+                <a:spcPts val="0"/>
+              </a:spcAft>
+              <a:buSzPts val="2400"/>
+              <a:buNone/>
+              <a:defRPr sz="2400" b="1"/>
+            </a:lvl3pPr>
+            <a:lvl4pPr lvl="3" rtl="0">
+              <a:lnSpc>
+                <a:spcPct val="100000"/>
+              </a:lnSpc>
+              <a:spcBef>
+                <a:spcPts val="0"/>
+              </a:spcBef>
+              <a:spcAft>
+                <a:spcPts val="0"/>
+              </a:spcAft>
+              <a:buSzPts val="2400"/>
+              <a:buNone/>
+              <a:defRPr sz="2400" b="1"/>
+            </a:lvl4pPr>
+            <a:lvl5pPr lvl="4" rtl="0">
+              <a:lnSpc>
+                <a:spcPct val="100000"/>
+              </a:lnSpc>
+              <a:spcBef>
+                <a:spcPts val="0"/>
+              </a:spcBef>
+              <a:spcAft>
+                <a:spcPts val="0"/>
+              </a:spcAft>
+              <a:buSzPts val="2400"/>
+              <a:buNone/>
+              <a:defRPr sz="2400" b="1"/>
+            </a:lvl5pPr>
+            <a:lvl6pPr lvl="5" rtl="0">
+              <a:lnSpc>
+                <a:spcPct val="100000"/>
+              </a:lnSpc>
+              <a:spcBef>
+                <a:spcPts val="0"/>
+              </a:spcBef>
+              <a:spcAft>
+                <a:spcPts val="0"/>
+              </a:spcAft>
+              <a:buSzPts val="2400"/>
+              <a:buNone/>
+              <a:defRPr sz="2400" b="1"/>
+            </a:lvl6pPr>
+            <a:lvl7pPr lvl="6" rtl="0">
+              <a:lnSpc>
+                <a:spcPct val="100000"/>
+              </a:lnSpc>
+              <a:spcBef>
+                <a:spcPts val="0"/>
+              </a:spcBef>
+              <a:spcAft>
+                <a:spcPts val="0"/>
+              </a:spcAft>
+              <a:buSzPts val="2400"/>
+              <a:buNone/>
+              <a:defRPr sz="2400" b="1"/>
+            </a:lvl7pPr>
+            <a:lvl8pPr lvl="7" rtl="0">
+              <a:lnSpc>
+                <a:spcPct val="100000"/>
+              </a:lnSpc>
+              <a:spcBef>
+                <a:spcPts val="0"/>
+              </a:spcBef>
+              <a:spcAft>
+                <a:spcPts val="0"/>
+              </a:spcAft>
+              <a:buSzPts val="2400"/>
+              <a:buNone/>
+              <a:defRPr sz="2400" b="1"/>
+            </a:lvl8pPr>
+            <a:lvl9pPr lvl="8" rtl="0">
+              <a:lnSpc>
+                <a:spcPct val="100000"/>
+              </a:lnSpc>
+              <a:spcBef>
+                <a:spcPts val="0"/>
+              </a:spcBef>
+              <a:spcAft>
+                <a:spcPts val="0"/>
+              </a:spcAft>
+              <a:buSzPts val="2400"/>
+              <a:buNone/>
+              <a:defRPr sz="2400" b="1"/>
+            </a:lvl9pPr>
+          </a:lstStyle>
+          <a:p>
+            <a:endParaRPr/>
+          </a:p>
+        </p:txBody>
+      </p:sp>
+      <p:sp>
+        <p:nvSpPr>
+          <p:cNvPr id="115" name="Google Shape;115;p13"/>
+          <p:cNvSpPr txBox="1">
+            <a:spLocks noGrp="1"/>
+          </p:cNvSpPr>
+          <p:nvPr>
+            <p:ph type="subTitle" idx="13"/>
+          </p:nvPr>
+        </p:nvSpPr>
+        <p:spPr>
+          <a:xfrm>
+            <a:off x="5575300" y="1699096"/>
+            <a:ext cx="2288100" cy="694800"/>
+          </a:xfrm>
+          <a:prstGeom prst="rect">
+            <a:avLst/>
+          </a:prstGeom>
+        </p:spPr>
+        <p:txBody>
+          <a:bodyPr spcFirstLastPara="1" wrap="square" lIns="91425" tIns="91425" rIns="91425" bIns="91425" anchor="ctr" anchorCtr="0">
+            <a:noAutofit/>
+          </a:bodyPr>
+          <a:lstStyle>
+            <a:lvl1pPr lvl="0" rtl="0">
+              <a:lnSpc>
+                <a:spcPct val="100000"/>
+              </a:lnSpc>
+              <a:spcBef>
+                <a:spcPts val="0"/>
+              </a:spcBef>
+              <a:spcAft>
+                <a:spcPts val="0"/>
+              </a:spcAft>
+              <a:buSzPts val="2400"/>
+              <a:buNone/>
+              <a:defRPr sz="1800" b="1">
+                <a:solidFill>
+                  <a:schemeClr val="dk1"/>
+                </a:solidFill>
+              </a:defRPr>
+            </a:lvl1pPr>
+            <a:lvl2pPr lvl="1" rtl="0">
+              <a:lnSpc>
+                <a:spcPct val="100000"/>
+              </a:lnSpc>
+              <a:spcBef>
+                <a:spcPts val="0"/>
+              </a:spcBef>
+              <a:spcAft>
+                <a:spcPts val="0"/>
+              </a:spcAft>
+              <a:buSzPts val="2400"/>
+              <a:buNone/>
+              <a:defRPr sz="2400" b="1"/>
+            </a:lvl2pPr>
+            <a:lvl3pPr lvl="2" rtl="0">
+              <a:lnSpc>
+                <a:spcPct val="100000"/>
+              </a:lnSpc>
+              <a:spcBef>
+                <a:spcPts val="0"/>
+              </a:spcBef>
+              <a:spcAft>
+                <a:spcPts val="0"/>
+              </a:spcAft>
+              <a:buSzPts val="2400"/>
+              <a:buNone/>
+              <a:defRPr sz="2400" b="1"/>
+            </a:lvl3pPr>
+            <a:lvl4pPr lvl="3" rtl="0">
+              <a:lnSpc>
+                <a:spcPct val="100000"/>
+              </a:lnSpc>
+              <a:spcBef>
+                <a:spcPts val="0"/>
+              </a:spcBef>
+              <a:spcAft>
+                <a:spcPts val="0"/>
+              </a:spcAft>
+              <a:buSzPts val="2400"/>
+              <a:buNone/>
+              <a:defRPr sz="2400" b="1"/>
+            </a:lvl4pPr>
+            <a:lvl5pPr lvl="4" rtl="0">
+              <a:lnSpc>
+                <a:spcPct val="100000"/>
+              </a:lnSpc>
+              <a:spcBef>
+                <a:spcPts val="0"/>
+              </a:spcBef>
+              <a:spcAft>
+                <a:spcPts val="0"/>
+              </a:spcAft>
+              <a:buSzPts val="2400"/>
+              <a:buNone/>
+              <a:defRPr sz="2400" b="1"/>
+            </a:lvl5pPr>
+            <a:lvl6pPr lvl="5" rtl="0">
+              <a:lnSpc>
+                <a:spcPct val="100000"/>
+              </a:lnSpc>
+              <a:spcBef>
+                <a:spcPts val="0"/>
+              </a:spcBef>
+              <a:spcAft>
+                <a:spcPts val="0"/>
+              </a:spcAft>
+              <a:buSzPts val="2400"/>
+              <a:buNone/>
+              <a:defRPr sz="2400" b="1"/>
+            </a:lvl6pPr>
+            <a:lvl7pPr lvl="6" rtl="0">
+              <a:lnSpc>
+                <a:spcPct val="100000"/>
+              </a:lnSpc>
+              <a:spcBef>
+                <a:spcPts val="0"/>
+              </a:spcBef>
+              <a:spcAft>
+                <a:spcPts val="0"/>
+              </a:spcAft>
+              <a:buSzPts val="2400"/>
+              <a:buNone/>
+              <a:defRPr sz="2400" b="1"/>
+            </a:lvl7pPr>
+            <a:lvl8pPr lvl="7" rtl="0">
+              <a:lnSpc>
+                <a:spcPct val="100000"/>
+              </a:lnSpc>
+              <a:spcBef>
+                <a:spcPts val="0"/>
+              </a:spcBef>
+              <a:spcAft>
+                <a:spcPts val="0"/>
+              </a:spcAft>
+              <a:buSzPts val="2400"/>
+              <a:buNone/>
+              <a:defRPr sz="2400" b="1"/>
+            </a:lvl8pPr>
+            <a:lvl9pPr lvl="8" rtl="0">
+              <a:lnSpc>
+                <a:spcPct val="100000"/>
+              </a:lnSpc>
+              <a:spcBef>
+                <a:spcPts val="0"/>
+              </a:spcBef>
+              <a:spcAft>
+                <a:spcPts val="0"/>
+              </a:spcAft>
+              <a:buSzPts val="2400"/>
+              <a:buNone/>
+              <a:defRPr sz="2400" b="1"/>
+            </a:lvl9pPr>
+          </a:lstStyle>
+          <a:p>
+            <a:endParaRPr/>
+          </a:p>
+        </p:txBody>
+      </p:sp>
+      <p:sp>
+        <p:nvSpPr>
+          <p:cNvPr id="116" name="Google Shape;116;p13"/>
+          <p:cNvSpPr txBox="1">
+            <a:spLocks noGrp="1"/>
+          </p:cNvSpPr>
+          <p:nvPr>
+            <p:ph type="subTitle" idx="14"/>
+          </p:nvPr>
+        </p:nvSpPr>
+        <p:spPr>
+          <a:xfrm>
+            <a:off x="5575300" y="2781754"/>
+            <a:ext cx="2288100" cy="694800"/>
+          </a:xfrm>
+          <a:prstGeom prst="rect">
+            <a:avLst/>
+          </a:prstGeom>
+        </p:spPr>
+        <p:txBody>
+          <a:bodyPr spcFirstLastPara="1" wrap="square" lIns="91425" tIns="91425" rIns="91425" bIns="91425" anchor="ctr" anchorCtr="0">
+            <a:noAutofit/>
+          </a:bodyPr>
+          <a:lstStyle>
+            <a:lvl1pPr lvl="0" rtl="0">
+              <a:lnSpc>
+                <a:spcPct val="100000"/>
+              </a:lnSpc>
+              <a:spcBef>
+                <a:spcPts val="0"/>
+              </a:spcBef>
+              <a:spcAft>
+                <a:spcPts val="0"/>
+              </a:spcAft>
+              <a:buSzPts val="2400"/>
+              <a:buNone/>
+              <a:defRPr sz="1800" b="1">
+                <a:solidFill>
+                  <a:schemeClr val="dk1"/>
+                </a:solidFill>
+              </a:defRPr>
+            </a:lvl1pPr>
+            <a:lvl2pPr lvl="1" rtl="0">
+              <a:lnSpc>
+                <a:spcPct val="100000"/>
+              </a:lnSpc>
+              <a:spcBef>
+                <a:spcPts val="0"/>
+              </a:spcBef>
+              <a:spcAft>
+                <a:spcPts val="0"/>
+              </a:spcAft>
+              <a:buSzPts val="2400"/>
+              <a:buNone/>
+              <a:defRPr sz="2400" b="1"/>
+            </a:lvl2pPr>
+            <a:lvl3pPr lvl="2" rtl="0">
+              <a:lnSpc>
+                <a:spcPct val="100000"/>
+              </a:lnSpc>
+              <a:spcBef>
+                <a:spcPts val="0"/>
+              </a:spcBef>
+              <a:spcAft>
+                <a:spcPts val="0"/>
+              </a:spcAft>
+              <a:buSzPts val="2400"/>
+              <a:buNone/>
+              <a:defRPr sz="2400" b="1"/>
+            </a:lvl3pPr>
+            <a:lvl4pPr lvl="3" rtl="0">
+              <a:lnSpc>
+                <a:spcPct val="100000"/>
+              </a:lnSpc>
+              <a:spcBef>
+                <a:spcPts val="0"/>
+              </a:spcBef>
+              <a:spcAft>
+                <a:spcPts val="0"/>
+              </a:spcAft>
+              <a:buSzPts val="2400"/>
+              <a:buNone/>
+              <a:defRPr sz="2400" b="1"/>
+            </a:lvl4pPr>
+            <a:lvl5pPr lvl="4" rtl="0">
+              <a:lnSpc>
+                <a:spcPct val="100000"/>
+              </a:lnSpc>
+              <a:spcBef>
+                <a:spcPts val="0"/>
+              </a:spcBef>
+              <a:spcAft>
+                <a:spcPts val="0"/>
+              </a:spcAft>
+              <a:buSzPts val="2400"/>
+              <a:buNone/>
+              <a:defRPr sz="2400" b="1"/>
+            </a:lvl5pPr>
+            <a:lvl6pPr lvl="5" rtl="0">
+              <a:lnSpc>
+                <a:spcPct val="100000"/>
+              </a:lnSpc>
+              <a:spcBef>
+                <a:spcPts val="0"/>
+              </a:spcBef>
+              <a:spcAft>
+                <a:spcPts val="0"/>
+              </a:spcAft>
+              <a:buSzPts val="2400"/>
+              <a:buNone/>
+              <a:defRPr sz="2400" b="1"/>
+            </a:lvl6pPr>
+            <a:lvl7pPr lvl="6" rtl="0">
+              <a:lnSpc>
+                <a:spcPct val="100000"/>
+              </a:lnSpc>
+              <a:spcBef>
+                <a:spcPts val="0"/>
+              </a:spcBef>
+              <a:spcAft>
+                <a:spcPts val="0"/>
+              </a:spcAft>
+              <a:buSzPts val="2400"/>
+              <a:buNone/>
+              <a:defRPr sz="2400" b="1"/>
+            </a:lvl7pPr>
+            <a:lvl8pPr lvl="7" rtl="0">
+              <a:lnSpc>
+                <a:spcPct val="100000"/>
+              </a:lnSpc>
+              <a:spcBef>
+                <a:spcPts val="0"/>
+              </a:spcBef>
+              <a:spcAft>
+                <a:spcPts val="0"/>
+              </a:spcAft>
+              <a:buSzPts val="2400"/>
+              <a:buNone/>
+              <a:defRPr sz="2400" b="1"/>
+            </a:lvl8pPr>
+            <a:lvl9pPr lvl="8" rtl="0">
+              <a:lnSpc>
+                <a:spcPct val="100000"/>
+              </a:lnSpc>
+              <a:spcBef>
+                <a:spcPts val="0"/>
+              </a:spcBef>
+              <a:spcAft>
+                <a:spcPts val="0"/>
+              </a:spcAft>
+              <a:buSzPts val="2400"/>
+              <a:buNone/>
+              <a:defRPr sz="2400" b="1"/>
+            </a:lvl9pPr>
+          </a:lstStyle>
+          <a:p>
+            <a:endParaRPr/>
+          </a:p>
+        </p:txBody>
+      </p:sp>
+      <p:sp>
+        <p:nvSpPr>
+          <p:cNvPr id="117" name="Google Shape;117;p13"/>
+          <p:cNvSpPr txBox="1">
+            <a:spLocks noGrp="1"/>
+          </p:cNvSpPr>
+          <p:nvPr>
+            <p:ph type="subTitle" idx="15"/>
+          </p:nvPr>
+        </p:nvSpPr>
+        <p:spPr>
+          <a:xfrm>
+            <a:off x="5575300" y="3864413"/>
+            <a:ext cx="2288100" cy="694800"/>
+          </a:xfrm>
+          <a:prstGeom prst="rect">
+            <a:avLst/>
+          </a:prstGeom>
+        </p:spPr>
+        <p:txBody>
+          <a:bodyPr spcFirstLastPara="1" wrap="square" lIns="91425" tIns="91425" rIns="91425" bIns="91425" anchor="ctr" anchorCtr="0">
+            <a:noAutofit/>
+          </a:bodyPr>
+          <a:lstStyle>
+            <a:lvl1pPr lvl="0" rtl="0">
+              <a:lnSpc>
+                <a:spcPct val="100000"/>
+              </a:lnSpc>
+              <a:spcBef>
+                <a:spcPts val="0"/>
+              </a:spcBef>
+              <a:spcAft>
+                <a:spcPts val="0"/>
+              </a:spcAft>
+              <a:buSzPts val="2400"/>
+              <a:buNone/>
+              <a:defRPr sz="1800" b="1">
+                <a:solidFill>
+                  <a:schemeClr val="dk1"/>
+                </a:solidFill>
+              </a:defRPr>
+            </a:lvl1pPr>
+            <a:lvl2pPr lvl="1" rtl="0">
+              <a:lnSpc>
+                <a:spcPct val="100000"/>
+              </a:lnSpc>
+              <a:spcBef>
+                <a:spcPts val="0"/>
+              </a:spcBef>
+              <a:spcAft>
+                <a:spcPts val="0"/>
+              </a:spcAft>
+              <a:buSzPts val="2400"/>
+              <a:buNone/>
+              <a:defRPr sz="2400" b="1"/>
+            </a:lvl2pPr>
+            <a:lvl3pPr lvl="2" rtl="0">
+              <a:lnSpc>
+                <a:spcPct val="100000"/>
+              </a:lnSpc>
+              <a:spcBef>
+                <a:spcPts val="0"/>
+              </a:spcBef>
+              <a:spcAft>
+                <a:spcPts val="0"/>
+              </a:spcAft>
+              <a:buSzPts val="2400"/>
+              <a:buNone/>
+              <a:defRPr sz="2400" b="1"/>
+            </a:lvl3pPr>
+            <a:lvl4pPr lvl="3" rtl="0">
+              <a:lnSpc>
+                <a:spcPct val="100000"/>
+              </a:lnSpc>
+              <a:spcBef>
+                <a:spcPts val="0"/>
+              </a:spcBef>
+              <a:spcAft>
+                <a:spcPts val="0"/>
+              </a:spcAft>
+              <a:buSzPts val="2400"/>
+              <a:buNone/>
+              <a:defRPr sz="2400" b="1"/>
+            </a:lvl4pPr>
+            <a:lvl5pPr lvl="4" rtl="0">
+              <a:lnSpc>
+                <a:spcPct val="100000"/>
+              </a:lnSpc>
+              <a:spcBef>
+                <a:spcPts val="0"/>
+              </a:spcBef>
+              <a:spcAft>
+                <a:spcPts val="0"/>
+              </a:spcAft>
+              <a:buSzPts val="2400"/>
+              <a:buNone/>
+              <a:defRPr sz="2400" b="1"/>
+            </a:lvl5pPr>
+            <a:lvl6pPr lvl="5" rtl="0">
+              <a:lnSpc>
+                <a:spcPct val="100000"/>
+              </a:lnSpc>
+              <a:spcBef>
+                <a:spcPts val="0"/>
+              </a:spcBef>
+              <a:spcAft>
+                <a:spcPts val="0"/>
+              </a:spcAft>
+              <a:buSzPts val="2400"/>
+              <a:buNone/>
+              <a:defRPr sz="2400" b="1"/>
+            </a:lvl6pPr>
+            <a:lvl7pPr lvl="6" rtl="0">
+              <a:lnSpc>
+                <a:spcPct val="100000"/>
+              </a:lnSpc>
+              <a:spcBef>
+                <a:spcPts val="0"/>
+              </a:spcBef>
+              <a:spcAft>
+                <a:spcPts val="0"/>
+              </a:spcAft>
+              <a:buSzPts val="2400"/>
+              <a:buNone/>
+              <a:defRPr sz="2400" b="1"/>
+            </a:lvl7pPr>
+            <a:lvl8pPr lvl="7" rtl="0">
+              <a:lnSpc>
+                <a:spcPct val="100000"/>
+              </a:lnSpc>
+              <a:spcBef>
+                <a:spcPts val="0"/>
+              </a:spcBef>
+              <a:spcAft>
+                <a:spcPts val="0"/>
+              </a:spcAft>
+              <a:buSzPts val="2400"/>
+              <a:buNone/>
+              <a:defRPr sz="2400" b="1"/>
+            </a:lvl8pPr>
+            <a:lvl9pPr lvl="8" rtl="0">
+              <a:lnSpc>
+                <a:spcPct val="100000"/>
+              </a:lnSpc>
+              <a:spcBef>
+                <a:spcPts val="0"/>
+              </a:spcBef>
+              <a:spcAft>
+                <a:spcPts val="0"/>
+              </a:spcAft>
+              <a:buSzPts val="2400"/>
+              <a:buNone/>
+              <a:defRPr sz="2400" b="1"/>
+            </a:lvl9pPr>
+          </a:lstStyle>
+          <a:p>
+            <a:endParaRPr/>
+          </a:p>
+        </p:txBody>
+      </p:sp>
+      <p:grpSp>
+        <p:nvGrpSpPr>
+          <p:cNvPr id="118" name="Google Shape;118;p13"/>
+          <p:cNvGrpSpPr/>
+          <p:nvPr/>
+        </p:nvGrpSpPr>
+        <p:grpSpPr>
+          <a:xfrm flipH="1">
+            <a:off x="2620475" y="0"/>
+            <a:ext cx="6523526" cy="369900"/>
+            <a:chOff x="0" y="0"/>
+            <a:chExt cx="6523526" cy="369900"/>
+          </a:xfrm>
+        </p:grpSpPr>
+        <p:pic>
+          <p:nvPicPr>
+            <p:cNvPr id="119" name="Google Shape;119;p13"/>
+            <p:cNvPicPr preferRelativeResize="0"/>
+            <p:nvPr/>
+          </p:nvPicPr>
+          <p:blipFill>
+            <a:blip r:embed="rId3">
+              <a:alphaModFix/>
+            </a:blip>
+            <a:stretch>
+              <a:fillRect/>
+            </a:stretch>
+          </p:blipFill>
+          <p:spPr>
+            <a:xfrm>
+              <a:off x="0" y="0"/>
+              <a:ext cx="6523526" cy="369900"/>
+            </a:xfrm>
+            <a:prstGeom prst="rect">
+              <a:avLst/>
+            </a:prstGeom>
+            <a:noFill/>
+            <a:ln>
+              <a:noFill/>
+            </a:ln>
+          </p:spPr>
+        </p:pic>
+        <p:pic>
+          <p:nvPicPr>
+            <p:cNvPr id="120" name="Google Shape;120;p13"/>
+            <p:cNvPicPr preferRelativeResize="0"/>
+            <p:nvPr/>
+          </p:nvPicPr>
+          <p:blipFill>
+            <a:blip r:embed="rId4">
+              <a:alphaModFix/>
+            </a:blip>
+            <a:stretch>
+              <a:fillRect/>
+            </a:stretch>
+          </p:blipFill>
+          <p:spPr>
+            <a:xfrm>
+              <a:off x="265125" y="150455"/>
+              <a:ext cx="1585464" cy="69000"/>
+            </a:xfrm>
+            <a:prstGeom prst="rect">
+              <a:avLst/>
+            </a:prstGeom>
+            <a:noFill/>
+            <a:ln>
+              <a:noFill/>
+            </a:ln>
+          </p:spPr>
+        </p:pic>
+      </p:grpSp>
+      <p:grpSp>
+        <p:nvGrpSpPr>
+          <p:cNvPr id="121" name="Google Shape;121;p13"/>
+          <p:cNvGrpSpPr/>
+          <p:nvPr/>
+        </p:nvGrpSpPr>
+        <p:grpSpPr>
+          <a:xfrm flipH="1">
+            <a:off x="0" y="0"/>
+            <a:ext cx="9144000" cy="5143512"/>
+            <a:chOff x="0" y="0"/>
+            <a:chExt cx="9144000" cy="5143512"/>
+          </a:xfrm>
+        </p:grpSpPr>
+        <p:pic>
+          <p:nvPicPr>
+            <p:cNvPr id="122" name="Google Shape;122;p13"/>
+            <p:cNvPicPr preferRelativeResize="0"/>
+            <p:nvPr/>
+          </p:nvPicPr>
+          <p:blipFill>
+            <a:blip r:embed="rId5">
+              <a:alphaModFix/>
+            </a:blip>
+            <a:stretch>
+              <a:fillRect/>
+            </a:stretch>
+          </p:blipFill>
+          <p:spPr>
+            <a:xfrm>
+              <a:off x="8171225" y="0"/>
+              <a:ext cx="972775" cy="972775"/>
+            </a:xfrm>
+            <a:prstGeom prst="rect">
+              <a:avLst/>
+            </a:prstGeom>
+            <a:noFill/>
+            <a:ln>
+              <a:noFill/>
+            </a:ln>
+          </p:spPr>
+        </p:pic>
+        <p:pic>
+          <p:nvPicPr>
+            <p:cNvPr id="123" name="Google Shape;123;p13"/>
+            <p:cNvPicPr preferRelativeResize="0"/>
+            <p:nvPr/>
+          </p:nvPicPr>
+          <p:blipFill>
+            <a:blip r:embed="rId6">
+              <a:alphaModFix/>
+            </a:blip>
+            <a:stretch>
+              <a:fillRect/>
+            </a:stretch>
+          </p:blipFill>
+          <p:spPr>
+            <a:xfrm>
+              <a:off x="0" y="4170737"/>
+              <a:ext cx="972775" cy="972775"/>
+            </a:xfrm>
+            <a:prstGeom prst="rect">
+              <a:avLst/>
+            </a:prstGeom>
+            <a:noFill/>
+            <a:ln>
+              <a:noFill/>
+            </a:ln>
+          </p:spPr>
+        </p:pic>
+      </p:grpSp>
+    </p:spTree>
+    <p:extLst>
+      <p:ext uri="{BB962C8B-B14F-4D97-AF65-F5344CB8AC3E}">
+        <p14:creationId xmlns:p14="http://schemas.microsoft.com/office/powerpoint/2010/main" val="2421212839"/>
+      </p:ext>
+    </p:extLst>
+  </p:cSld>
+  <p:clrMapOvr>
+    <a:masterClrMapping/>
+  </p:clrMapOvr>
+</p:sldLayout>
+</file>
+
 <file path=ppt/slideLayouts/slideLayout2.xml><?xml version="1.0" encoding="utf-8"?>
 <p:sldLayout xmlns:a="http://schemas.openxmlformats.org/drawingml/2006/main" xmlns:r="http://schemas.openxmlformats.org/officeDocument/2006/relationships" xmlns:p="http://schemas.openxmlformats.org/presentationml/2006/main" matchingName="One column text">
   <p:cSld name="ONE_COLUMN_TEXT">
@@ -9534,6 +11769,7 @@
     <p:sldLayoutId id="2147483666" r:id="rId10"/>
     <p:sldLayoutId id="2147483671" r:id="rId11"/>
     <p:sldLayoutId id="2147483676" r:id="rId12"/>
+    <p:sldLayoutId id="2147483681" r:id="rId13"/>
   </p:sldLayoutIdLst>
   <p:hf hdr="0" ftr="0" dt="0"/>
   <p:txStyles>
@@ -10364,6 +12600,138 @@
   <p:cSld>
     <p:spTree>
       <p:nvGrpSpPr>
+        <p:cNvPr id="1" name="Shape 328">
+          <a:extLst>
+            <a:ext uri="{FF2B5EF4-FFF2-40B4-BE49-F238E27FC236}">
+              <a16:creationId xmlns:a16="http://schemas.microsoft.com/office/drawing/2014/main" id="{505F5346-EFD1-E363-B0E8-70B041F9D149}"/>
+            </a:ext>
+          </a:extLst>
+        </p:cNvPr>
+        <p:cNvGrpSpPr/>
+        <p:nvPr/>
+      </p:nvGrpSpPr>
+      <p:grpSpPr>
+        <a:xfrm>
+          <a:off x="0" y="0"/>
+          <a:ext cx="0" cy="0"/>
+          <a:chOff x="0" y="0"/>
+          <a:chExt cx="0" cy="0"/>
+        </a:xfrm>
+      </p:grpSpPr>
+      <p:sp>
+        <p:nvSpPr>
+          <p:cNvPr id="329" name="Google Shape;329;p35">
+            <a:extLst>
+              <a:ext uri="{FF2B5EF4-FFF2-40B4-BE49-F238E27FC236}">
+                <a16:creationId xmlns:a16="http://schemas.microsoft.com/office/drawing/2014/main" id="{EFE7F7D2-921F-FB5C-0BE3-0E92E4EBEA4F}"/>
+              </a:ext>
+            </a:extLst>
+          </p:cNvPr>
+          <p:cNvSpPr txBox="1">
+            <a:spLocks noGrp="1"/>
+          </p:cNvSpPr>
+          <p:nvPr>
+            <p:ph type="ctrTitle"/>
+          </p:nvPr>
+        </p:nvSpPr>
+        <p:spPr>
+          <a:xfrm>
+            <a:off x="972300" y="1482800"/>
+            <a:ext cx="7199400" cy="1477200"/>
+          </a:xfrm>
+          <a:prstGeom prst="rect">
+            <a:avLst/>
+          </a:prstGeom>
+        </p:spPr>
+        <p:txBody>
+          <a:bodyPr spcFirstLastPara="1" wrap="square" lIns="91425" tIns="91425" rIns="91425" bIns="91425" anchor="b" anchorCtr="0">
+            <a:noAutofit/>
+          </a:bodyPr>
+          <a:lstStyle/>
+          <a:p>
+            <a:pPr marL="0" lvl="0" indent="0" algn="l" rtl="0">
+              <a:spcBef>
+                <a:spcPts val="0"/>
+              </a:spcBef>
+              <a:spcAft>
+                <a:spcPts val="0"/>
+              </a:spcAft>
+              <a:buNone/>
+            </a:pPr>
+            <a:r>
+              <a:rPr lang="en" dirty="0"/>
+              <a:t>Alternativa B: Multimodal</a:t>
+            </a:r>
+            <a:endParaRPr dirty="0"/>
+          </a:p>
+        </p:txBody>
+      </p:sp>
+      <p:sp>
+        <p:nvSpPr>
+          <p:cNvPr id="330" name="Google Shape;330;p35">
+            <a:extLst>
+              <a:ext uri="{FF2B5EF4-FFF2-40B4-BE49-F238E27FC236}">
+                <a16:creationId xmlns:a16="http://schemas.microsoft.com/office/drawing/2014/main" id="{0570BF8F-EECA-65FE-7238-50380D30996E}"/>
+              </a:ext>
+            </a:extLst>
+          </p:cNvPr>
+          <p:cNvSpPr txBox="1">
+            <a:spLocks noGrp="1"/>
+          </p:cNvSpPr>
+          <p:nvPr>
+            <p:ph type="subTitle" idx="1"/>
+          </p:nvPr>
+        </p:nvSpPr>
+        <p:spPr>
+          <a:xfrm>
+            <a:off x="972300" y="3239202"/>
+            <a:ext cx="7199400" cy="421500"/>
+          </a:xfrm>
+          <a:prstGeom prst="rect">
+            <a:avLst/>
+          </a:prstGeom>
+        </p:spPr>
+        <p:txBody>
+          <a:bodyPr spcFirstLastPara="1" wrap="square" lIns="91425" tIns="91425" rIns="91425" bIns="91425" anchor="t" anchorCtr="0">
+            <a:noAutofit/>
+          </a:bodyPr>
+          <a:lstStyle/>
+          <a:p>
+            <a:pPr marL="0" lvl="0" indent="0" algn="l" rtl="0">
+              <a:spcBef>
+                <a:spcPts val="0"/>
+              </a:spcBef>
+              <a:spcAft>
+                <a:spcPts val="0"/>
+              </a:spcAft>
+              <a:buNone/>
+            </a:pPr>
+            <a:r>
+              <a:rPr lang="pt-BR" dirty="0"/>
+              <a:t>Integração entre trechos rodoviários e transporte por cabotagem</a:t>
+            </a:r>
+            <a:endParaRPr dirty="0"/>
+          </a:p>
+        </p:txBody>
+      </p:sp>
+    </p:spTree>
+    <p:extLst>
+      <p:ext uri="{BB962C8B-B14F-4D97-AF65-F5344CB8AC3E}">
+        <p14:creationId xmlns:p14="http://schemas.microsoft.com/office/powerpoint/2010/main" val="3533937004"/>
+      </p:ext>
+    </p:extLst>
+  </p:cSld>
+  <p:clrMapOvr>
+    <a:masterClrMapping/>
+  </p:clrMapOvr>
+</p:sld>
+</file>
+
+<file path=ppt/slides/slide11.xml><?xml version="1.0" encoding="utf-8"?>
+<p:sld xmlns:a="http://schemas.openxmlformats.org/drawingml/2006/main" xmlns:r="http://schemas.openxmlformats.org/officeDocument/2006/relationships" xmlns:p="http://schemas.openxmlformats.org/presentationml/2006/main">
+  <p:cSld>
+    <p:spTree>
+      <p:nvGrpSpPr>
         <p:cNvPr id="1" name="Shape 442">
           <a:extLst>
             <a:ext uri="{FF2B5EF4-FFF2-40B4-BE49-F238E27FC236}">
@@ -11395,7 +13763,7 @@
 </p:sld>
 </file>
 
-<file path=ppt/slides/slide11.xml><?xml version="1.0" encoding="utf-8"?>
+<file path=ppt/slides/slide12.xml><?xml version="1.0" encoding="utf-8"?>
 <p:sld xmlns:a="http://schemas.openxmlformats.org/drawingml/2006/main" xmlns:r="http://schemas.openxmlformats.org/officeDocument/2006/relationships" xmlns:p="http://schemas.openxmlformats.org/presentationml/2006/main">
   <p:cSld>
     <p:spTree>
@@ -12273,7 +14641,7 @@
 </p:sld>
 </file>
 
-<file path=ppt/slides/slide12.xml><?xml version="1.0" encoding="utf-8"?>
+<file path=ppt/slides/slide13.xml><?xml version="1.0" encoding="utf-8"?>
 <p:sld xmlns:a="http://schemas.openxmlformats.org/drawingml/2006/main" xmlns:r="http://schemas.openxmlformats.org/officeDocument/2006/relationships" xmlns:p="http://schemas.openxmlformats.org/presentationml/2006/main">
   <p:cSld>
     <p:spTree>
@@ -13173,7 +15541,1084 @@
 </p:sld>
 </file>
 
-<file path=ppt/slides/slide13.xml><?xml version="1.0" encoding="utf-8"?>
+<file path=ppt/slides/slide14.xml><?xml version="1.0" encoding="utf-8"?>
+<p:sld xmlns:a="http://schemas.openxmlformats.org/drawingml/2006/main" xmlns:r="http://schemas.openxmlformats.org/officeDocument/2006/relationships" xmlns:p="http://schemas.openxmlformats.org/presentationml/2006/main">
+  <p:cSld>
+    <p:spTree>
+      <p:nvGrpSpPr>
+        <p:cNvPr id="1" name="Shape 343"/>
+        <p:cNvGrpSpPr/>
+        <p:nvPr/>
+      </p:nvGrpSpPr>
+      <p:grpSpPr>
+        <a:xfrm>
+          <a:off x="0" y="0"/>
+          <a:ext cx="0" cy="0"/>
+          <a:chOff x="0" y="0"/>
+          <a:chExt cx="0" cy="0"/>
+        </a:xfrm>
+      </p:grpSpPr>
+      <p:sp>
+        <p:nvSpPr>
+          <p:cNvPr id="344" name="Google Shape;344;p37"/>
+          <p:cNvSpPr txBox="1">
+            <a:spLocks noGrp="1"/>
+          </p:cNvSpPr>
+          <p:nvPr>
+            <p:ph type="title"/>
+          </p:nvPr>
+        </p:nvSpPr>
+        <p:spPr>
+          <a:xfrm>
+            <a:off x="720000" y="539500"/>
+            <a:ext cx="7704000" cy="572700"/>
+          </a:xfrm>
+          <a:prstGeom prst="rect">
+            <a:avLst/>
+          </a:prstGeom>
+        </p:spPr>
+        <p:txBody>
+          <a:bodyPr spcFirstLastPara="1" wrap="square" lIns="91425" tIns="91425" rIns="91425" bIns="91425" anchor="t" anchorCtr="0">
+            <a:noAutofit/>
+          </a:bodyPr>
+          <a:lstStyle/>
+          <a:p>
+            <a:r>
+              <a:rPr lang="pt-BR" sz="3200" dirty="0"/>
+              <a:t>Consumo na perna marítima</a:t>
+            </a:r>
+          </a:p>
+        </p:txBody>
+      </p:sp>
+      <p:sp>
+        <p:nvSpPr>
+          <p:cNvPr id="345" name="Google Shape;345;p37"/>
+          <p:cNvSpPr txBox="1">
+            <a:spLocks noGrp="1"/>
+          </p:cNvSpPr>
+          <p:nvPr>
+            <p:ph type="title" idx="2"/>
+          </p:nvPr>
+        </p:nvSpPr>
+        <p:spPr>
+          <a:xfrm>
+            <a:off x="3759205" y="1699096"/>
+            <a:ext cx="694800" cy="694800"/>
+          </a:xfrm>
+          <a:prstGeom prst="rect">
+            <a:avLst/>
+          </a:prstGeom>
+        </p:spPr>
+        <p:txBody>
+          <a:bodyPr spcFirstLastPara="1" wrap="square" lIns="91425" tIns="91425" rIns="91425" bIns="91425" anchor="ctr" anchorCtr="0">
+            <a:noAutofit/>
+          </a:bodyPr>
+          <a:lstStyle/>
+          <a:p>
+            <a:pPr marL="0" lvl="0" indent="0" algn="ctr" rtl="0">
+              <a:spcBef>
+                <a:spcPts val="0"/>
+              </a:spcBef>
+              <a:spcAft>
+                <a:spcPts val="0"/>
+              </a:spcAft>
+              <a:buNone/>
+            </a:pPr>
+            <a:r>
+              <a:rPr lang="en"/>
+              <a:t>01</a:t>
+            </a:r>
+            <a:endParaRPr/>
+          </a:p>
+        </p:txBody>
+      </p:sp>
+      <p:sp>
+        <p:nvSpPr>
+          <p:cNvPr id="346" name="Google Shape;346;p37"/>
+          <p:cNvSpPr txBox="1">
+            <a:spLocks noGrp="1"/>
+          </p:cNvSpPr>
+          <p:nvPr>
+            <p:ph type="title" idx="3"/>
+          </p:nvPr>
+        </p:nvSpPr>
+        <p:spPr>
+          <a:xfrm>
+            <a:off x="4690005" y="1699096"/>
+            <a:ext cx="694800" cy="694800"/>
+          </a:xfrm>
+          <a:prstGeom prst="rect">
+            <a:avLst/>
+          </a:prstGeom>
+        </p:spPr>
+        <p:txBody>
+          <a:bodyPr spcFirstLastPara="1" wrap="square" lIns="91425" tIns="91425" rIns="91425" bIns="91425" anchor="ctr" anchorCtr="0">
+            <a:noAutofit/>
+          </a:bodyPr>
+          <a:lstStyle/>
+          <a:p>
+            <a:pPr marL="0" lvl="0" indent="0" algn="ctr" rtl="0">
+              <a:spcBef>
+                <a:spcPts val="0"/>
+              </a:spcBef>
+              <a:spcAft>
+                <a:spcPts val="0"/>
+              </a:spcAft>
+              <a:buNone/>
+            </a:pPr>
+            <a:r>
+              <a:rPr lang="en"/>
+              <a:t>04</a:t>
+            </a:r>
+            <a:endParaRPr/>
+          </a:p>
+        </p:txBody>
+      </p:sp>
+      <p:sp>
+        <p:nvSpPr>
+          <p:cNvPr id="347" name="Google Shape;347;p37"/>
+          <p:cNvSpPr txBox="1">
+            <a:spLocks noGrp="1"/>
+          </p:cNvSpPr>
+          <p:nvPr>
+            <p:ph type="title" idx="4"/>
+          </p:nvPr>
+        </p:nvSpPr>
+        <p:spPr>
+          <a:xfrm>
+            <a:off x="3759193" y="2781754"/>
+            <a:ext cx="694800" cy="694800"/>
+          </a:xfrm>
+          <a:prstGeom prst="rect">
+            <a:avLst/>
+          </a:prstGeom>
+        </p:spPr>
+        <p:txBody>
+          <a:bodyPr spcFirstLastPara="1" wrap="square" lIns="91425" tIns="91425" rIns="91425" bIns="91425" anchor="ctr" anchorCtr="0">
+            <a:noAutofit/>
+          </a:bodyPr>
+          <a:lstStyle/>
+          <a:p>
+            <a:pPr marL="0" lvl="0" indent="0" algn="ctr" rtl="0">
+              <a:spcBef>
+                <a:spcPts val="0"/>
+              </a:spcBef>
+              <a:spcAft>
+                <a:spcPts val="0"/>
+              </a:spcAft>
+              <a:buNone/>
+            </a:pPr>
+            <a:r>
+              <a:rPr lang="en"/>
+              <a:t>02</a:t>
+            </a:r>
+            <a:endParaRPr/>
+          </a:p>
+        </p:txBody>
+      </p:sp>
+      <p:sp>
+        <p:nvSpPr>
+          <p:cNvPr id="348" name="Google Shape;348;p37"/>
+          <p:cNvSpPr txBox="1">
+            <a:spLocks noGrp="1"/>
+          </p:cNvSpPr>
+          <p:nvPr>
+            <p:ph type="title" idx="5"/>
+          </p:nvPr>
+        </p:nvSpPr>
+        <p:spPr>
+          <a:xfrm>
+            <a:off x="4689993" y="2781754"/>
+            <a:ext cx="694800" cy="694800"/>
+          </a:xfrm>
+          <a:prstGeom prst="rect">
+            <a:avLst/>
+          </a:prstGeom>
+        </p:spPr>
+        <p:txBody>
+          <a:bodyPr spcFirstLastPara="1" wrap="square" lIns="91425" tIns="91425" rIns="91425" bIns="91425" anchor="ctr" anchorCtr="0">
+            <a:noAutofit/>
+          </a:bodyPr>
+          <a:lstStyle/>
+          <a:p>
+            <a:pPr marL="0" lvl="0" indent="0" algn="ctr" rtl="0">
+              <a:spcBef>
+                <a:spcPts val="0"/>
+              </a:spcBef>
+              <a:spcAft>
+                <a:spcPts val="0"/>
+              </a:spcAft>
+              <a:buNone/>
+            </a:pPr>
+            <a:r>
+              <a:rPr lang="en"/>
+              <a:t>05</a:t>
+            </a:r>
+            <a:endParaRPr/>
+          </a:p>
+        </p:txBody>
+      </p:sp>
+      <p:sp>
+        <p:nvSpPr>
+          <p:cNvPr id="349" name="Google Shape;349;p37"/>
+          <p:cNvSpPr txBox="1">
+            <a:spLocks noGrp="1"/>
+          </p:cNvSpPr>
+          <p:nvPr>
+            <p:ph type="title" idx="6"/>
+          </p:nvPr>
+        </p:nvSpPr>
+        <p:spPr>
+          <a:xfrm>
+            <a:off x="3759207" y="3864413"/>
+            <a:ext cx="694800" cy="694800"/>
+          </a:xfrm>
+          <a:prstGeom prst="rect">
+            <a:avLst/>
+          </a:prstGeom>
+        </p:spPr>
+        <p:txBody>
+          <a:bodyPr spcFirstLastPara="1" wrap="square" lIns="91425" tIns="91425" rIns="91425" bIns="91425" anchor="ctr" anchorCtr="0">
+            <a:noAutofit/>
+          </a:bodyPr>
+          <a:lstStyle/>
+          <a:p>
+            <a:pPr marL="0" lvl="0" indent="0" algn="ctr" rtl="0">
+              <a:spcBef>
+                <a:spcPts val="0"/>
+              </a:spcBef>
+              <a:spcAft>
+                <a:spcPts val="0"/>
+              </a:spcAft>
+              <a:buNone/>
+            </a:pPr>
+            <a:r>
+              <a:rPr lang="en"/>
+              <a:t>03</a:t>
+            </a:r>
+            <a:endParaRPr/>
+          </a:p>
+        </p:txBody>
+      </p:sp>
+      <p:sp>
+        <p:nvSpPr>
+          <p:cNvPr id="350" name="Google Shape;350;p37"/>
+          <p:cNvSpPr txBox="1">
+            <a:spLocks noGrp="1"/>
+          </p:cNvSpPr>
+          <p:nvPr>
+            <p:ph type="title" idx="7"/>
+          </p:nvPr>
+        </p:nvSpPr>
+        <p:spPr>
+          <a:xfrm>
+            <a:off x="4690007" y="3864413"/>
+            <a:ext cx="694800" cy="694800"/>
+          </a:xfrm>
+          <a:prstGeom prst="rect">
+            <a:avLst/>
+          </a:prstGeom>
+        </p:spPr>
+        <p:txBody>
+          <a:bodyPr spcFirstLastPara="1" wrap="square" lIns="91425" tIns="91425" rIns="91425" bIns="91425" anchor="ctr" anchorCtr="0">
+            <a:noAutofit/>
+          </a:bodyPr>
+          <a:lstStyle/>
+          <a:p>
+            <a:pPr marL="0" lvl="0" indent="0" algn="ctr" rtl="0">
+              <a:spcBef>
+                <a:spcPts val="0"/>
+              </a:spcBef>
+              <a:spcAft>
+                <a:spcPts val="0"/>
+              </a:spcAft>
+              <a:buNone/>
+            </a:pPr>
+            <a:r>
+              <a:rPr lang="en"/>
+              <a:t>06</a:t>
+            </a:r>
+            <a:endParaRPr/>
+          </a:p>
+        </p:txBody>
+      </p:sp>
+      <p:sp>
+        <p:nvSpPr>
+          <p:cNvPr id="351" name="Google Shape;351;p37"/>
+          <p:cNvSpPr txBox="1">
+            <a:spLocks noGrp="1"/>
+          </p:cNvSpPr>
+          <p:nvPr>
+            <p:ph type="subTitle" idx="1"/>
+          </p:nvPr>
+        </p:nvSpPr>
+        <p:spPr>
+          <a:xfrm>
+            <a:off x="1280600" y="1699100"/>
+            <a:ext cx="2288100" cy="694800"/>
+          </a:xfrm>
+          <a:prstGeom prst="rect">
+            <a:avLst/>
+          </a:prstGeom>
+        </p:spPr>
+        <p:txBody>
+          <a:bodyPr spcFirstLastPara="1" wrap="square" lIns="91425" tIns="91425" rIns="91425" bIns="91425" anchor="ctr" anchorCtr="0">
+            <a:noAutofit/>
+          </a:bodyPr>
+          <a:lstStyle/>
+          <a:p>
+            <a:pPr marL="0" lvl="0" indent="0" algn="r" rtl="0">
+              <a:spcBef>
+                <a:spcPts val="0"/>
+              </a:spcBef>
+              <a:spcAft>
+                <a:spcPts val="0"/>
+              </a:spcAft>
+              <a:buNone/>
+            </a:pPr>
+            <a:r>
+              <a:rPr lang="pt-BR" dirty="0"/>
+              <a:t>Análise de dados reais da ANTAQ</a:t>
+            </a:r>
+            <a:endParaRPr dirty="0"/>
+          </a:p>
+        </p:txBody>
+      </p:sp>
+      <p:sp>
+        <p:nvSpPr>
+          <p:cNvPr id="352" name="Google Shape;352;p37"/>
+          <p:cNvSpPr txBox="1">
+            <a:spLocks noGrp="1"/>
+          </p:cNvSpPr>
+          <p:nvPr>
+            <p:ph type="subTitle" idx="8"/>
+          </p:nvPr>
+        </p:nvSpPr>
+        <p:spPr>
+          <a:xfrm>
+            <a:off x="1280600" y="2781762"/>
+            <a:ext cx="2288100" cy="694800"/>
+          </a:xfrm>
+          <a:prstGeom prst="rect">
+            <a:avLst/>
+          </a:prstGeom>
+        </p:spPr>
+        <p:txBody>
+          <a:bodyPr spcFirstLastPara="1" wrap="square" lIns="91425" tIns="91425" rIns="91425" bIns="91425" anchor="ctr" anchorCtr="0">
+            <a:noAutofit/>
+          </a:bodyPr>
+          <a:lstStyle/>
+          <a:p>
+            <a:pPr marL="0" lvl="0" indent="0" algn="r" rtl="0">
+              <a:spcBef>
+                <a:spcPts val="0"/>
+              </a:spcBef>
+              <a:spcAft>
+                <a:spcPts val="0"/>
+              </a:spcAft>
+              <a:buNone/>
+            </a:pPr>
+            <a:endParaRPr dirty="0"/>
+          </a:p>
+        </p:txBody>
+      </p:sp>
+      <p:sp>
+        <p:nvSpPr>
+          <p:cNvPr id="353" name="Google Shape;353;p37"/>
+          <p:cNvSpPr txBox="1">
+            <a:spLocks noGrp="1"/>
+          </p:cNvSpPr>
+          <p:nvPr>
+            <p:ph type="subTitle" idx="9"/>
+          </p:nvPr>
+        </p:nvSpPr>
+        <p:spPr>
+          <a:xfrm>
+            <a:off x="1280600" y="3864423"/>
+            <a:ext cx="2288100" cy="694800"/>
+          </a:xfrm>
+          <a:prstGeom prst="rect">
+            <a:avLst/>
+          </a:prstGeom>
+        </p:spPr>
+        <p:txBody>
+          <a:bodyPr spcFirstLastPara="1" wrap="square" lIns="91425" tIns="91425" rIns="91425" bIns="91425" anchor="ctr" anchorCtr="0">
+            <a:noAutofit/>
+          </a:bodyPr>
+          <a:lstStyle/>
+          <a:p>
+            <a:pPr marL="0" lvl="0" indent="0" algn="r" rtl="0">
+              <a:spcBef>
+                <a:spcPts val="0"/>
+              </a:spcBef>
+              <a:spcAft>
+                <a:spcPts val="0"/>
+              </a:spcAft>
+              <a:buNone/>
+            </a:pPr>
+            <a:r>
+              <a:rPr lang="en"/>
+              <a:t>BUDGET</a:t>
+            </a:r>
+            <a:endParaRPr/>
+          </a:p>
+        </p:txBody>
+      </p:sp>
+      <p:sp>
+        <p:nvSpPr>
+          <p:cNvPr id="354" name="Google Shape;354;p37"/>
+          <p:cNvSpPr txBox="1">
+            <a:spLocks noGrp="1"/>
+          </p:cNvSpPr>
+          <p:nvPr>
+            <p:ph type="subTitle" idx="13"/>
+          </p:nvPr>
+        </p:nvSpPr>
+        <p:spPr>
+          <a:xfrm>
+            <a:off x="5575300" y="1699096"/>
+            <a:ext cx="2288100" cy="694800"/>
+          </a:xfrm>
+          <a:prstGeom prst="rect">
+            <a:avLst/>
+          </a:prstGeom>
+        </p:spPr>
+        <p:txBody>
+          <a:bodyPr spcFirstLastPara="1" wrap="square" lIns="91425" tIns="91425" rIns="91425" bIns="91425" anchor="ctr" anchorCtr="0">
+            <a:noAutofit/>
+          </a:bodyPr>
+          <a:lstStyle/>
+          <a:p>
+            <a:pPr marL="0" lvl="0" indent="0" algn="l" rtl="0">
+              <a:spcBef>
+                <a:spcPts val="0"/>
+              </a:spcBef>
+              <a:spcAft>
+                <a:spcPts val="0"/>
+              </a:spcAft>
+              <a:buNone/>
+            </a:pPr>
+            <a:r>
+              <a:rPr lang="en"/>
+              <a:t>SOLUTIONS</a:t>
+            </a:r>
+            <a:endParaRPr/>
+          </a:p>
+        </p:txBody>
+      </p:sp>
+      <p:sp>
+        <p:nvSpPr>
+          <p:cNvPr id="355" name="Google Shape;355;p37"/>
+          <p:cNvSpPr txBox="1">
+            <a:spLocks noGrp="1"/>
+          </p:cNvSpPr>
+          <p:nvPr>
+            <p:ph type="subTitle" idx="14"/>
+          </p:nvPr>
+        </p:nvSpPr>
+        <p:spPr>
+          <a:xfrm>
+            <a:off x="5575300" y="2781754"/>
+            <a:ext cx="2288100" cy="694800"/>
+          </a:xfrm>
+          <a:prstGeom prst="rect">
+            <a:avLst/>
+          </a:prstGeom>
+        </p:spPr>
+        <p:txBody>
+          <a:bodyPr spcFirstLastPara="1" wrap="square" lIns="91425" tIns="91425" rIns="91425" bIns="91425" anchor="ctr" anchorCtr="0">
+            <a:noAutofit/>
+          </a:bodyPr>
+          <a:lstStyle/>
+          <a:p>
+            <a:pPr marL="0" lvl="0" indent="0" algn="l" rtl="0">
+              <a:spcBef>
+                <a:spcPts val="0"/>
+              </a:spcBef>
+              <a:spcAft>
+                <a:spcPts val="0"/>
+              </a:spcAft>
+              <a:buNone/>
+            </a:pPr>
+            <a:r>
+              <a:rPr lang="en"/>
+              <a:t>COMMUNICATION PLAN</a:t>
+            </a:r>
+            <a:endParaRPr/>
+          </a:p>
+        </p:txBody>
+      </p:sp>
+      <p:sp>
+        <p:nvSpPr>
+          <p:cNvPr id="356" name="Google Shape;356;p37"/>
+          <p:cNvSpPr txBox="1">
+            <a:spLocks noGrp="1"/>
+          </p:cNvSpPr>
+          <p:nvPr>
+            <p:ph type="subTitle" idx="15"/>
+          </p:nvPr>
+        </p:nvSpPr>
+        <p:spPr>
+          <a:xfrm>
+            <a:off x="5575300" y="3864413"/>
+            <a:ext cx="2288100" cy="694800"/>
+          </a:xfrm>
+          <a:prstGeom prst="rect">
+            <a:avLst/>
+          </a:prstGeom>
+        </p:spPr>
+        <p:txBody>
+          <a:bodyPr spcFirstLastPara="1" wrap="square" lIns="91425" tIns="91425" rIns="91425" bIns="91425" anchor="ctr" anchorCtr="0">
+            <a:noAutofit/>
+          </a:bodyPr>
+          <a:lstStyle/>
+          <a:p>
+            <a:pPr marL="0" lvl="0" indent="0" algn="l" rtl="0">
+              <a:spcBef>
+                <a:spcPts val="0"/>
+              </a:spcBef>
+              <a:spcAft>
+                <a:spcPts val="0"/>
+              </a:spcAft>
+              <a:buNone/>
+            </a:pPr>
+            <a:r>
+              <a:rPr lang="en"/>
+              <a:t>CONCLUSION</a:t>
+            </a:r>
+            <a:endParaRPr/>
+          </a:p>
+        </p:txBody>
+      </p:sp>
+      <p:pic>
+        <p:nvPicPr>
+          <p:cNvPr id="357" name="Google Shape;357;p37"/>
+          <p:cNvPicPr preferRelativeResize="0"/>
+          <p:nvPr/>
+        </p:nvPicPr>
+        <p:blipFill>
+          <a:blip r:embed="rId3">
+            <a:alphaModFix/>
+          </a:blip>
+          <a:stretch>
+            <a:fillRect/>
+          </a:stretch>
+        </p:blipFill>
+        <p:spPr>
+          <a:xfrm>
+            <a:off x="76200" y="3712050"/>
+            <a:ext cx="1768000" cy="1350575"/>
+          </a:xfrm>
+          <a:prstGeom prst="rect">
+            <a:avLst/>
+          </a:prstGeom>
+          <a:noFill/>
+          <a:ln>
+            <a:noFill/>
+          </a:ln>
+        </p:spPr>
+      </p:pic>
+      <p:sp>
+        <p:nvSpPr>
+          <p:cNvPr id="3" name="Google Shape;330;p35">
+            <a:extLst>
+              <a:ext uri="{FF2B5EF4-FFF2-40B4-BE49-F238E27FC236}">
+                <a16:creationId xmlns:a16="http://schemas.microsoft.com/office/drawing/2014/main" id="{C83FF82B-5B3B-294F-2915-E8F0F63AD4AC}"/>
+              </a:ext>
+            </a:extLst>
+          </p:cNvPr>
+          <p:cNvSpPr txBox="1">
+            <a:spLocks/>
+          </p:cNvSpPr>
+          <p:nvPr/>
+        </p:nvSpPr>
+        <p:spPr>
+          <a:xfrm>
+            <a:off x="720000" y="1113764"/>
+            <a:ext cx="7704000" cy="317686"/>
+          </a:xfrm>
+          <a:prstGeom prst="rect">
+            <a:avLst/>
+          </a:prstGeom>
+          <a:noFill/>
+          <a:ln>
+            <a:noFill/>
+          </a:ln>
+        </p:spPr>
+        <p:txBody>
+          <a:bodyPr spcFirstLastPara="1" wrap="square" lIns="91425" tIns="91425" rIns="91425" bIns="91425" anchor="t" anchorCtr="0">
+            <a:noAutofit/>
+          </a:bodyPr>
+          <a:lstStyle>
+            <a:defPPr marR="0" lvl="0" algn="l" rtl="0">
+              <a:lnSpc>
+                <a:spcPct val="100000"/>
+              </a:lnSpc>
+              <a:spcBef>
+                <a:spcPts val="0"/>
+              </a:spcBef>
+              <a:spcAft>
+                <a:spcPts val="0"/>
+              </a:spcAft>
+            </a:defPPr>
+            <a:lvl1pPr marL="457200" marR="0" lvl="0" indent="-304800" algn="l" rtl="0">
+              <a:lnSpc>
+                <a:spcPct val="100000"/>
+              </a:lnSpc>
+              <a:spcBef>
+                <a:spcPts val="0"/>
+              </a:spcBef>
+              <a:spcAft>
+                <a:spcPts val="0"/>
+              </a:spcAft>
+              <a:buClr>
+                <a:schemeClr val="dk1"/>
+              </a:buClr>
+              <a:buSzPts val="1200"/>
+              <a:buFont typeface="Poppins"/>
+              <a:buNone/>
+              <a:defRPr sz="1200" b="0" i="0" u="none" strike="noStrike" cap="none">
+                <a:solidFill>
+                  <a:schemeClr val="dk1"/>
+                </a:solidFill>
+                <a:latin typeface="Poppins"/>
+                <a:ea typeface="Poppins"/>
+                <a:cs typeface="Poppins"/>
+                <a:sym typeface="Poppins"/>
+              </a:defRPr>
+            </a:lvl1pPr>
+            <a:lvl2pPr marL="914400" marR="0" lvl="1" indent="-304800" algn="ctr" rtl="0">
+              <a:lnSpc>
+                <a:spcPct val="100000"/>
+              </a:lnSpc>
+              <a:spcBef>
+                <a:spcPts val="0"/>
+              </a:spcBef>
+              <a:spcAft>
+                <a:spcPts val="0"/>
+              </a:spcAft>
+              <a:buClr>
+                <a:schemeClr val="dk1"/>
+              </a:buClr>
+              <a:buSzPts val="1200"/>
+              <a:buFont typeface="Poppins"/>
+              <a:buNone/>
+              <a:defRPr sz="1200" b="0" i="0" u="none" strike="noStrike" cap="none">
+                <a:solidFill>
+                  <a:schemeClr val="dk1"/>
+                </a:solidFill>
+                <a:latin typeface="Poppins"/>
+                <a:ea typeface="Poppins"/>
+                <a:cs typeface="Poppins"/>
+                <a:sym typeface="Poppins"/>
+              </a:defRPr>
+            </a:lvl2pPr>
+            <a:lvl3pPr marL="1371600" marR="0" lvl="2" indent="-304800" algn="ctr" rtl="0">
+              <a:lnSpc>
+                <a:spcPct val="100000"/>
+              </a:lnSpc>
+              <a:spcBef>
+                <a:spcPts val="0"/>
+              </a:spcBef>
+              <a:spcAft>
+                <a:spcPts val="0"/>
+              </a:spcAft>
+              <a:buClr>
+                <a:schemeClr val="dk1"/>
+              </a:buClr>
+              <a:buSzPts val="1200"/>
+              <a:buFont typeface="Poppins"/>
+              <a:buNone/>
+              <a:defRPr sz="1200" b="0" i="0" u="none" strike="noStrike" cap="none">
+                <a:solidFill>
+                  <a:schemeClr val="dk1"/>
+                </a:solidFill>
+                <a:latin typeface="Poppins"/>
+                <a:ea typeface="Poppins"/>
+                <a:cs typeface="Poppins"/>
+                <a:sym typeface="Poppins"/>
+              </a:defRPr>
+            </a:lvl3pPr>
+            <a:lvl4pPr marL="1828800" marR="0" lvl="3" indent="-304800" algn="ctr" rtl="0">
+              <a:lnSpc>
+                <a:spcPct val="100000"/>
+              </a:lnSpc>
+              <a:spcBef>
+                <a:spcPts val="0"/>
+              </a:spcBef>
+              <a:spcAft>
+                <a:spcPts val="0"/>
+              </a:spcAft>
+              <a:buClr>
+                <a:schemeClr val="dk1"/>
+              </a:buClr>
+              <a:buSzPts val="1200"/>
+              <a:buFont typeface="Poppins"/>
+              <a:buNone/>
+              <a:defRPr sz="1200" b="0" i="0" u="none" strike="noStrike" cap="none">
+                <a:solidFill>
+                  <a:schemeClr val="dk1"/>
+                </a:solidFill>
+                <a:latin typeface="Poppins"/>
+                <a:ea typeface="Poppins"/>
+                <a:cs typeface="Poppins"/>
+                <a:sym typeface="Poppins"/>
+              </a:defRPr>
+            </a:lvl4pPr>
+            <a:lvl5pPr marL="2286000" marR="0" lvl="4" indent="-304800" algn="ctr" rtl="0">
+              <a:lnSpc>
+                <a:spcPct val="100000"/>
+              </a:lnSpc>
+              <a:spcBef>
+                <a:spcPts val="0"/>
+              </a:spcBef>
+              <a:spcAft>
+                <a:spcPts val="0"/>
+              </a:spcAft>
+              <a:buClr>
+                <a:schemeClr val="dk1"/>
+              </a:buClr>
+              <a:buSzPts val="1200"/>
+              <a:buFont typeface="Poppins"/>
+              <a:buNone/>
+              <a:defRPr sz="1200" b="0" i="0" u="none" strike="noStrike" cap="none">
+                <a:solidFill>
+                  <a:schemeClr val="dk1"/>
+                </a:solidFill>
+                <a:latin typeface="Poppins"/>
+                <a:ea typeface="Poppins"/>
+                <a:cs typeface="Poppins"/>
+                <a:sym typeface="Poppins"/>
+              </a:defRPr>
+            </a:lvl5pPr>
+            <a:lvl6pPr marL="2743200" marR="0" lvl="5" indent="-304800" algn="ctr" rtl="0">
+              <a:lnSpc>
+                <a:spcPct val="100000"/>
+              </a:lnSpc>
+              <a:spcBef>
+                <a:spcPts val="0"/>
+              </a:spcBef>
+              <a:spcAft>
+                <a:spcPts val="0"/>
+              </a:spcAft>
+              <a:buClr>
+                <a:schemeClr val="dk1"/>
+              </a:buClr>
+              <a:buSzPts val="1200"/>
+              <a:buFont typeface="Poppins"/>
+              <a:buNone/>
+              <a:defRPr sz="1200" b="0" i="0" u="none" strike="noStrike" cap="none">
+                <a:solidFill>
+                  <a:schemeClr val="dk1"/>
+                </a:solidFill>
+                <a:latin typeface="Poppins"/>
+                <a:ea typeface="Poppins"/>
+                <a:cs typeface="Poppins"/>
+                <a:sym typeface="Poppins"/>
+              </a:defRPr>
+            </a:lvl6pPr>
+            <a:lvl7pPr marL="3200400" marR="0" lvl="6" indent="-304800" algn="ctr" rtl="0">
+              <a:lnSpc>
+                <a:spcPct val="100000"/>
+              </a:lnSpc>
+              <a:spcBef>
+                <a:spcPts val="0"/>
+              </a:spcBef>
+              <a:spcAft>
+                <a:spcPts val="0"/>
+              </a:spcAft>
+              <a:buClr>
+                <a:schemeClr val="dk1"/>
+              </a:buClr>
+              <a:buSzPts val="1200"/>
+              <a:buFont typeface="Poppins"/>
+              <a:buNone/>
+              <a:defRPr sz="1200" b="0" i="0" u="none" strike="noStrike" cap="none">
+                <a:solidFill>
+                  <a:schemeClr val="dk1"/>
+                </a:solidFill>
+                <a:latin typeface="Poppins"/>
+                <a:ea typeface="Poppins"/>
+                <a:cs typeface="Poppins"/>
+                <a:sym typeface="Poppins"/>
+              </a:defRPr>
+            </a:lvl7pPr>
+            <a:lvl8pPr marL="3657600" marR="0" lvl="7" indent="-304800" algn="ctr" rtl="0">
+              <a:lnSpc>
+                <a:spcPct val="100000"/>
+              </a:lnSpc>
+              <a:spcBef>
+                <a:spcPts val="0"/>
+              </a:spcBef>
+              <a:spcAft>
+                <a:spcPts val="0"/>
+              </a:spcAft>
+              <a:buClr>
+                <a:schemeClr val="dk1"/>
+              </a:buClr>
+              <a:buSzPts val="1200"/>
+              <a:buFont typeface="Poppins"/>
+              <a:buNone/>
+              <a:defRPr sz="1200" b="0" i="0" u="none" strike="noStrike" cap="none">
+                <a:solidFill>
+                  <a:schemeClr val="dk1"/>
+                </a:solidFill>
+                <a:latin typeface="Poppins"/>
+                <a:ea typeface="Poppins"/>
+                <a:cs typeface="Poppins"/>
+                <a:sym typeface="Poppins"/>
+              </a:defRPr>
+            </a:lvl8pPr>
+            <a:lvl9pPr marL="4114800" marR="0" lvl="8" indent="-304800" algn="ctr" rtl="0">
+              <a:lnSpc>
+                <a:spcPct val="100000"/>
+              </a:lnSpc>
+              <a:spcBef>
+                <a:spcPts val="0"/>
+              </a:spcBef>
+              <a:spcAft>
+                <a:spcPts val="0"/>
+              </a:spcAft>
+              <a:buClr>
+                <a:schemeClr val="dk1"/>
+              </a:buClr>
+              <a:buSzPts val="1200"/>
+              <a:buFont typeface="Poppins"/>
+              <a:buNone/>
+              <a:defRPr sz="1200" b="0" i="0" u="none" strike="noStrike" cap="none">
+                <a:solidFill>
+                  <a:schemeClr val="dk1"/>
+                </a:solidFill>
+                <a:latin typeface="Poppins"/>
+                <a:ea typeface="Poppins"/>
+                <a:cs typeface="Poppins"/>
+                <a:sym typeface="Poppins"/>
+              </a:defRPr>
+            </a:lvl9pPr>
+          </a:lstStyle>
+          <a:p>
+            <a:pPr marL="0" indent="0" algn="ctr"/>
+            <a:r>
+              <a:rPr lang="pt-BR" sz="1000" i="1" dirty="0"/>
+              <a:t>Passo a passo para o cálculo do consumo de combustível na perna marítima </a:t>
+            </a:r>
+            <a:endParaRPr lang="en-US" sz="1000" i="1" dirty="0"/>
+          </a:p>
+        </p:txBody>
+      </p:sp>
+    </p:spTree>
+  </p:cSld>
+  <p:clrMapOvr>
+    <a:masterClrMapping/>
+  </p:clrMapOvr>
+</p:sld>
+</file>
+
+<file path=ppt/slides/slide15.xml><?xml version="1.0" encoding="utf-8"?>
+<p:sld xmlns:a="http://schemas.openxmlformats.org/drawingml/2006/main" xmlns:r="http://schemas.openxmlformats.org/officeDocument/2006/relationships" xmlns:p="http://schemas.openxmlformats.org/presentationml/2006/main">
+  <p:cSld>
+    <p:spTree>
+      <p:nvGrpSpPr>
+        <p:cNvPr id="1" name=""/>
+        <p:cNvGrpSpPr/>
+        <p:nvPr/>
+      </p:nvGrpSpPr>
+      <p:grpSpPr>
+        <a:xfrm>
+          <a:off x="0" y="0"/>
+          <a:ext cx="0" cy="0"/>
+          <a:chOff x="0" y="0"/>
+          <a:chExt cx="0" cy="0"/>
+        </a:xfrm>
+      </p:grpSpPr>
+      <p:sp>
+        <p:nvSpPr>
+          <p:cNvPr id="6" name="Título 5">
+            <a:extLst>
+              <a:ext uri="{FF2B5EF4-FFF2-40B4-BE49-F238E27FC236}">
+                <a16:creationId xmlns:a16="http://schemas.microsoft.com/office/drawing/2014/main" id="{143373FB-FEF6-6C40-484D-6EA118157CAA}"/>
+              </a:ext>
+            </a:extLst>
+          </p:cNvPr>
+          <p:cNvSpPr>
+            <a:spLocks noGrp="1"/>
+          </p:cNvSpPr>
+          <p:nvPr>
+            <p:ph type="title"/>
+          </p:nvPr>
+        </p:nvSpPr>
+        <p:spPr/>
+        <p:txBody>
+          <a:bodyPr/>
+          <a:lstStyle/>
+          <a:p>
+            <a:r>
+              <a:rPr lang="pt-BR" dirty="0"/>
+              <a:t>Análise de dados de navegação</a:t>
+            </a:r>
+          </a:p>
+        </p:txBody>
+      </p:sp>
+      <p:sp>
+        <p:nvSpPr>
+          <p:cNvPr id="7" name="Subtítulo 6">
+            <a:extLst>
+              <a:ext uri="{FF2B5EF4-FFF2-40B4-BE49-F238E27FC236}">
+                <a16:creationId xmlns:a16="http://schemas.microsoft.com/office/drawing/2014/main" id="{9A6C8322-8023-4406-8599-23B64BC1B044}"/>
+              </a:ext>
+            </a:extLst>
+          </p:cNvPr>
+          <p:cNvSpPr>
+            <a:spLocks noGrp="1"/>
+          </p:cNvSpPr>
+          <p:nvPr>
+            <p:ph type="subTitle" idx="1"/>
+          </p:nvPr>
+        </p:nvSpPr>
+        <p:spPr>
+          <a:xfrm>
+            <a:off x="720000" y="1429886"/>
+            <a:ext cx="3549600" cy="3174114"/>
+          </a:xfrm>
+        </p:spPr>
+        <p:txBody>
+          <a:bodyPr/>
+          <a:lstStyle/>
+          <a:p>
+            <a:r>
+              <a:rPr lang="pt-BR" b="1"/>
+              <a:t>Objetivo:</a:t>
+            </a:r>
+            <a:r>
+              <a:rPr lang="pt-BR"/>
+              <a:t> usar os dados da ANTAQ para reconstruir, por </a:t>
+            </a:r>
+            <a:r>
+              <a:rPr lang="pt-BR" b="1"/>
+              <a:t>IMO</a:t>
+            </a:r>
+            <a:r>
+              <a:rPr lang="pt-BR"/>
+              <a:t>, quanto de carga cada navio transportava ao longo dos trechos de cabotagem observados</a:t>
+            </a:r>
+            <a:endParaRPr lang="pt-BR" dirty="0"/>
+          </a:p>
+        </p:txBody>
+      </p:sp>
+      <p:sp>
+        <p:nvSpPr>
+          <p:cNvPr id="8" name="Subtítulo 7">
+            <a:extLst>
+              <a:ext uri="{FF2B5EF4-FFF2-40B4-BE49-F238E27FC236}">
+                <a16:creationId xmlns:a16="http://schemas.microsoft.com/office/drawing/2014/main" id="{6F2B90E2-871C-8F53-49D9-639D1AE7B1D5}"/>
+              </a:ext>
+            </a:extLst>
+          </p:cNvPr>
+          <p:cNvSpPr>
+            <a:spLocks noGrp="1"/>
+          </p:cNvSpPr>
+          <p:nvPr>
+            <p:ph type="subTitle" idx="2"/>
+          </p:nvPr>
+        </p:nvSpPr>
+        <p:spPr/>
+        <p:txBody>
+          <a:bodyPr/>
+          <a:lstStyle/>
+          <a:p>
+            <a:endParaRPr lang="pt-BR"/>
+          </a:p>
+        </p:txBody>
+      </p:sp>
+      <p:sp>
+        <p:nvSpPr>
+          <p:cNvPr id="10" name="Subtítulo 9">
+            <a:extLst>
+              <a:ext uri="{FF2B5EF4-FFF2-40B4-BE49-F238E27FC236}">
+                <a16:creationId xmlns:a16="http://schemas.microsoft.com/office/drawing/2014/main" id="{87A9381B-FA9D-74BD-7DE5-BB424ABD7FAB}"/>
+              </a:ext>
+            </a:extLst>
+          </p:cNvPr>
+          <p:cNvSpPr>
+            <a:spLocks noGrp="1"/>
+          </p:cNvSpPr>
+          <p:nvPr>
+            <p:ph type="subTitle" idx="4"/>
+          </p:nvPr>
+        </p:nvSpPr>
+        <p:spPr/>
+        <p:txBody>
+          <a:bodyPr/>
+          <a:lstStyle/>
+          <a:p>
+            <a:endParaRPr lang="pt-BR"/>
+          </a:p>
+        </p:txBody>
+      </p:sp>
+      <p:sp>
+        <p:nvSpPr>
+          <p:cNvPr id="13" name="Subtítulo 12">
+            <a:extLst>
+              <a:ext uri="{FF2B5EF4-FFF2-40B4-BE49-F238E27FC236}">
+                <a16:creationId xmlns:a16="http://schemas.microsoft.com/office/drawing/2014/main" id="{4F64FB41-1AF0-80EE-86CC-787ED936D2DE}"/>
+              </a:ext>
+            </a:extLst>
+          </p:cNvPr>
+          <p:cNvSpPr>
+            <a:spLocks noGrp="1"/>
+          </p:cNvSpPr>
+          <p:nvPr>
+            <p:ph type="subTitle" idx="7"/>
+          </p:nvPr>
+        </p:nvSpPr>
+        <p:spPr/>
+        <p:txBody>
+          <a:bodyPr/>
+          <a:lstStyle/>
+          <a:p>
+            <a:endParaRPr lang="pt-BR"/>
+          </a:p>
+        </p:txBody>
+      </p:sp>
+      <p:sp>
+        <p:nvSpPr>
+          <p:cNvPr id="14" name="Subtítulo 13">
+            <a:extLst>
+              <a:ext uri="{FF2B5EF4-FFF2-40B4-BE49-F238E27FC236}">
+                <a16:creationId xmlns:a16="http://schemas.microsoft.com/office/drawing/2014/main" id="{6CB01A18-7CB8-EB0F-5CC3-61ABB3BD4A3C}"/>
+              </a:ext>
+            </a:extLst>
+          </p:cNvPr>
+          <p:cNvSpPr>
+            <a:spLocks noGrp="1"/>
+          </p:cNvSpPr>
+          <p:nvPr>
+            <p:ph type="subTitle" idx="8"/>
+          </p:nvPr>
+        </p:nvSpPr>
+        <p:spPr/>
+        <p:txBody>
+          <a:bodyPr/>
+          <a:lstStyle/>
+          <a:p>
+            <a:endParaRPr lang="pt-BR"/>
+          </a:p>
+        </p:txBody>
+      </p:sp>
+    </p:spTree>
+    <p:extLst>
+      <p:ext uri="{BB962C8B-B14F-4D97-AF65-F5344CB8AC3E}">
+        <p14:creationId xmlns:p14="http://schemas.microsoft.com/office/powerpoint/2010/main" val="573013424"/>
+      </p:ext>
+    </p:extLst>
+  </p:cSld>
+  <p:clrMapOvr>
+    <a:masterClrMapping/>
+  </p:clrMapOvr>
+</p:sld>
+</file>
+
+<file path=ppt/slides/slide16.xml><?xml version="1.0" encoding="utf-8"?>
 <p:sld xmlns:a="http://schemas.openxmlformats.org/drawingml/2006/main" xmlns:r="http://schemas.openxmlformats.org/officeDocument/2006/relationships" xmlns:p="http://schemas.openxmlformats.org/presentationml/2006/main">
   <p:cSld>
     <p:spTree>
@@ -14324,7 +17769,67 @@
 </p:sld>
 </file>
 
-<file path=ppt/slides/slide14.xml><?xml version="1.0" encoding="utf-8"?>
+<file path=ppt/slides/slide17.xml><?xml version="1.0" encoding="utf-8"?>
+<p:sld xmlns:a="http://schemas.openxmlformats.org/drawingml/2006/main" xmlns:r="http://schemas.openxmlformats.org/officeDocument/2006/relationships" xmlns:p="http://schemas.openxmlformats.org/presentationml/2006/main">
+  <p:cSld>
+    <p:spTree>
+      <p:nvGrpSpPr>
+        <p:cNvPr id="1" name=""/>
+        <p:cNvGrpSpPr/>
+        <p:nvPr/>
+      </p:nvGrpSpPr>
+      <p:grpSpPr>
+        <a:xfrm>
+          <a:off x="0" y="0"/>
+          <a:ext cx="0" cy="0"/>
+          <a:chOff x="0" y="0"/>
+          <a:chExt cx="0" cy="0"/>
+        </a:xfrm>
+      </p:grpSpPr>
+      <p:pic>
+        <p:nvPicPr>
+          <p:cNvPr id="17" name="Imagem 16">
+            <a:extLst>
+              <a:ext uri="{FF2B5EF4-FFF2-40B4-BE49-F238E27FC236}">
+                <a16:creationId xmlns:a16="http://schemas.microsoft.com/office/drawing/2014/main" id="{7889D027-6CBB-4680-5100-9624F38EA7DE}"/>
+              </a:ext>
+            </a:extLst>
+          </p:cNvPr>
+          <p:cNvPicPr>
+            <a:picLocks noChangeAspect="1"/>
+          </p:cNvPicPr>
+          <p:nvPr/>
+        </p:nvPicPr>
+        <p:blipFill>
+          <a:blip r:embed="rId2"/>
+          <a:stretch>
+            <a:fillRect/>
+          </a:stretch>
+        </p:blipFill>
+        <p:spPr>
+          <a:xfrm>
+            <a:off x="2220686" y="827314"/>
+            <a:ext cx="3533008" cy="3387271"/>
+          </a:xfrm>
+          <a:prstGeom prst="rect">
+            <a:avLst/>
+          </a:prstGeom>
+        </p:spPr>
+      </p:pic>
+    </p:spTree>
+    <p:extLst>
+      <p:ext uri="{BB962C8B-B14F-4D97-AF65-F5344CB8AC3E}">
+        <p14:creationId xmlns:p14="http://schemas.microsoft.com/office/powerpoint/2010/main" val="71646819"/>
+      </p:ext>
+    </p:extLst>
+  </p:cSld>
+  <p:clrMapOvr>
+    <a:masterClrMapping/>
+  </p:clrMapOvr>
+</p:sld>
+</file>
+
+<file path=ppt/slides/slide18.xml><?xml version="1.0" encoding="utf-8"?>
 <p:sld xmlns:a="http://schemas.openxmlformats.org/drawingml/2006/main" xmlns:r="http://schemas.openxmlformats.org/officeDocument/2006/relationships" xmlns:p="http://schemas.openxmlformats.org/presentationml/2006/main">
   <p:cSld>
     <p:spTree>
@@ -14390,7 +17895,7 @@
 </p:sld>
 </file>
 
-<file path=ppt/slides/slide15.xml><?xml version="1.0" encoding="utf-8"?>
+<file path=ppt/slides/slide19.xml><?xml version="1.0" encoding="utf-8"?>
 <p:sld xmlns:a="http://schemas.openxmlformats.org/drawingml/2006/main" xmlns:r="http://schemas.openxmlformats.org/officeDocument/2006/relationships" xmlns:p="http://schemas.openxmlformats.org/presentationml/2006/main">
   <p:cSld>
     <p:spTree>
@@ -15085,7 +18590,121 @@
 </p:sld>
 </file>
 
-<file path=ppt/slides/slide16.xml><?xml version="1.0" encoding="utf-8"?>
+<file path=ppt/slides/slide2.xml><?xml version="1.0" encoding="utf-8"?>
+<p:sld xmlns:a="http://schemas.openxmlformats.org/drawingml/2006/main" xmlns:r="http://schemas.openxmlformats.org/officeDocument/2006/relationships" xmlns:p="http://schemas.openxmlformats.org/presentationml/2006/main">
+  <p:cSld>
+    <p:spTree>
+      <p:nvGrpSpPr>
+        <p:cNvPr id="1" name="Shape 514">
+          <a:extLst>
+            <a:ext uri="{FF2B5EF4-FFF2-40B4-BE49-F238E27FC236}">
+              <a16:creationId xmlns:a16="http://schemas.microsoft.com/office/drawing/2014/main" id="{45B23727-CC23-1091-FADE-8C3E7550DAD4}"/>
+            </a:ext>
+          </a:extLst>
+        </p:cNvPr>
+        <p:cNvGrpSpPr/>
+        <p:nvPr/>
+      </p:nvGrpSpPr>
+      <p:grpSpPr>
+        <a:xfrm>
+          <a:off x="0" y="0"/>
+          <a:ext cx="0" cy="0"/>
+          <a:chOff x="0" y="0"/>
+          <a:chExt cx="0" cy="0"/>
+        </a:xfrm>
+      </p:grpSpPr>
+      <p:sp>
+        <p:nvSpPr>
+          <p:cNvPr id="515" name="Google Shape;515;p50">
+            <a:extLst>
+              <a:ext uri="{FF2B5EF4-FFF2-40B4-BE49-F238E27FC236}">
+                <a16:creationId xmlns:a16="http://schemas.microsoft.com/office/drawing/2014/main" id="{66D091F1-8AD9-FA68-25D0-F7570F24F63B}"/>
+              </a:ext>
+            </a:extLst>
+          </p:cNvPr>
+          <p:cNvSpPr txBox="1">
+            <a:spLocks noGrp="1"/>
+          </p:cNvSpPr>
+          <p:nvPr>
+            <p:ph type="title"/>
+          </p:nvPr>
+        </p:nvSpPr>
+        <p:spPr>
+          <a:xfrm>
+            <a:off x="277200" y="440283"/>
+            <a:ext cx="4294800" cy="647299"/>
+          </a:xfrm>
+          <a:prstGeom prst="rect">
+            <a:avLst/>
+          </a:prstGeom>
+        </p:spPr>
+        <p:txBody>
+          <a:bodyPr spcFirstLastPara="1" wrap="square" lIns="91425" tIns="91425" rIns="91425" bIns="91425" anchor="t" anchorCtr="0">
+            <a:noAutofit/>
+          </a:bodyPr>
+          <a:lstStyle/>
+          <a:p>
+            <a:pPr marL="0" lvl="0" indent="0" algn="ctr" rtl="0">
+              <a:spcBef>
+                <a:spcPts val="0"/>
+              </a:spcBef>
+              <a:spcAft>
+                <a:spcPts val="0"/>
+              </a:spcAft>
+              <a:buNone/>
+            </a:pPr>
+            <a:r>
+              <a:rPr lang="en" dirty="0"/>
+              <a:t>Alternativas de rota</a:t>
+            </a:r>
+            <a:endParaRPr dirty="0"/>
+          </a:p>
+        </p:txBody>
+      </p:sp>
+      <p:pic>
+        <p:nvPicPr>
+          <p:cNvPr id="21" name="Imagem 20">
+            <a:extLst>
+              <a:ext uri="{FF2B5EF4-FFF2-40B4-BE49-F238E27FC236}">
+                <a16:creationId xmlns:a16="http://schemas.microsoft.com/office/drawing/2014/main" id="{A06E01C4-6246-D147-7008-2AF924B3870A}"/>
+              </a:ext>
+            </a:extLst>
+          </p:cNvPr>
+          <p:cNvPicPr>
+            <a:picLocks noChangeAspect="1"/>
+          </p:cNvPicPr>
+          <p:nvPr/>
+        </p:nvPicPr>
+        <p:blipFill>
+          <a:blip r:embed="rId3"/>
+          <a:stretch>
+            <a:fillRect/>
+          </a:stretch>
+        </p:blipFill>
+        <p:spPr>
+          <a:xfrm>
+            <a:off x="0" y="1087582"/>
+            <a:ext cx="9060666" cy="4055918"/>
+          </a:xfrm>
+          <a:prstGeom prst="rect">
+            <a:avLst/>
+          </a:prstGeom>
+        </p:spPr>
+      </p:pic>
+    </p:spTree>
+    <p:extLst>
+      <p:ext uri="{BB962C8B-B14F-4D97-AF65-F5344CB8AC3E}">
+        <p14:creationId xmlns:p14="http://schemas.microsoft.com/office/powerpoint/2010/main" val="3075856904"/>
+      </p:ext>
+    </p:extLst>
+  </p:cSld>
+  <p:clrMapOvr>
+    <a:masterClrMapping/>
+  </p:clrMapOvr>
+</p:sld>
+</file>
+
+<file path=ppt/slides/slide20.xml><?xml version="1.0" encoding="utf-8"?>
 <p:sld xmlns:a="http://schemas.openxmlformats.org/drawingml/2006/main" xmlns:r="http://schemas.openxmlformats.org/officeDocument/2006/relationships" xmlns:p="http://schemas.openxmlformats.org/presentationml/2006/main">
   <p:cSld>
     <p:spTree>
@@ -15217,7 +18836,7 @@
 </p:sld>
 </file>
 
-<file path=ppt/slides/slide17.xml><?xml version="1.0" encoding="utf-8"?>
+<file path=ppt/slides/slide21.xml><?xml version="1.0" encoding="utf-8"?>
 <p:sld xmlns:a="http://schemas.openxmlformats.org/drawingml/2006/main" xmlns:r="http://schemas.openxmlformats.org/officeDocument/2006/relationships" xmlns:p="http://schemas.openxmlformats.org/presentationml/2006/main">
   <p:cSld>
     <p:spTree>
@@ -15519,7 +19138,7 @@
 </p:sld>
 </file>
 
-<file path=ppt/slides/slide18.xml><?xml version="1.0" encoding="utf-8"?>
+<file path=ppt/slides/slide22.xml><?xml version="1.0" encoding="utf-8"?>
 <p:sld xmlns:a="http://schemas.openxmlformats.org/drawingml/2006/main" xmlns:r="http://schemas.openxmlformats.org/officeDocument/2006/relationships" xmlns:p="http://schemas.openxmlformats.org/presentationml/2006/main">
   <p:cSld>
     <p:spTree>
@@ -15660,120 +19279,6 @@
     <p:extLst>
       <p:ext uri="{BB962C8B-B14F-4D97-AF65-F5344CB8AC3E}">
         <p14:creationId xmlns:p14="http://schemas.microsoft.com/office/powerpoint/2010/main" val="2952461991"/>
-      </p:ext>
-    </p:extLst>
-  </p:cSld>
-  <p:clrMapOvr>
-    <a:masterClrMapping/>
-  </p:clrMapOvr>
-</p:sld>
-</file>
-
-<file path=ppt/slides/slide2.xml><?xml version="1.0" encoding="utf-8"?>
-<p:sld xmlns:a="http://schemas.openxmlformats.org/drawingml/2006/main" xmlns:r="http://schemas.openxmlformats.org/officeDocument/2006/relationships" xmlns:p="http://schemas.openxmlformats.org/presentationml/2006/main">
-  <p:cSld>
-    <p:spTree>
-      <p:nvGrpSpPr>
-        <p:cNvPr id="1" name="Shape 514">
-          <a:extLst>
-            <a:ext uri="{FF2B5EF4-FFF2-40B4-BE49-F238E27FC236}">
-              <a16:creationId xmlns:a16="http://schemas.microsoft.com/office/drawing/2014/main" id="{45B23727-CC23-1091-FADE-8C3E7550DAD4}"/>
-            </a:ext>
-          </a:extLst>
-        </p:cNvPr>
-        <p:cNvGrpSpPr/>
-        <p:nvPr/>
-      </p:nvGrpSpPr>
-      <p:grpSpPr>
-        <a:xfrm>
-          <a:off x="0" y="0"/>
-          <a:ext cx="0" cy="0"/>
-          <a:chOff x="0" y="0"/>
-          <a:chExt cx="0" cy="0"/>
-        </a:xfrm>
-      </p:grpSpPr>
-      <p:sp>
-        <p:nvSpPr>
-          <p:cNvPr id="515" name="Google Shape;515;p50">
-            <a:extLst>
-              <a:ext uri="{FF2B5EF4-FFF2-40B4-BE49-F238E27FC236}">
-                <a16:creationId xmlns:a16="http://schemas.microsoft.com/office/drawing/2014/main" id="{66D091F1-8AD9-FA68-25D0-F7570F24F63B}"/>
-              </a:ext>
-            </a:extLst>
-          </p:cNvPr>
-          <p:cNvSpPr txBox="1">
-            <a:spLocks noGrp="1"/>
-          </p:cNvSpPr>
-          <p:nvPr>
-            <p:ph type="title"/>
-          </p:nvPr>
-        </p:nvSpPr>
-        <p:spPr>
-          <a:xfrm>
-            <a:off x="277200" y="440283"/>
-            <a:ext cx="4294800" cy="647299"/>
-          </a:xfrm>
-          <a:prstGeom prst="rect">
-            <a:avLst/>
-          </a:prstGeom>
-        </p:spPr>
-        <p:txBody>
-          <a:bodyPr spcFirstLastPara="1" wrap="square" lIns="91425" tIns="91425" rIns="91425" bIns="91425" anchor="t" anchorCtr="0">
-            <a:noAutofit/>
-          </a:bodyPr>
-          <a:lstStyle/>
-          <a:p>
-            <a:pPr marL="0" lvl="0" indent="0" algn="ctr" rtl="0">
-              <a:spcBef>
-                <a:spcPts val="0"/>
-              </a:spcBef>
-              <a:spcAft>
-                <a:spcPts val="0"/>
-              </a:spcAft>
-              <a:buNone/>
-            </a:pPr>
-            <a:r>
-              <a:rPr lang="en" dirty="0"/>
-              <a:t>Alternativas de rota</a:t>
-            </a:r>
-            <a:endParaRPr dirty="0"/>
-          </a:p>
-        </p:txBody>
-      </p:sp>
-      <p:pic>
-        <p:nvPicPr>
-          <p:cNvPr id="21" name="Imagem 20">
-            <a:extLst>
-              <a:ext uri="{FF2B5EF4-FFF2-40B4-BE49-F238E27FC236}">
-                <a16:creationId xmlns:a16="http://schemas.microsoft.com/office/drawing/2014/main" id="{A06E01C4-6246-D147-7008-2AF924B3870A}"/>
-              </a:ext>
-            </a:extLst>
-          </p:cNvPr>
-          <p:cNvPicPr>
-            <a:picLocks noChangeAspect="1"/>
-          </p:cNvPicPr>
-          <p:nvPr/>
-        </p:nvPicPr>
-        <p:blipFill>
-          <a:blip r:embed="rId3"/>
-          <a:stretch>
-            <a:fillRect/>
-          </a:stretch>
-        </p:blipFill>
-        <p:spPr>
-          <a:xfrm>
-            <a:off x="0" y="1087582"/>
-            <a:ext cx="9060666" cy="4055918"/>
-          </a:xfrm>
-          <a:prstGeom prst="rect">
-            <a:avLst/>
-          </a:prstGeom>
-        </p:spPr>
-      </p:pic>
-    </p:spTree>
-    <p:extLst>
-      <p:ext uri="{BB962C8B-B14F-4D97-AF65-F5344CB8AC3E}">
-        <p14:creationId xmlns:p14="http://schemas.microsoft.com/office/powerpoint/2010/main" val="3075856904"/>
       </p:ext>
     </p:extLst>
   </p:cSld>
@@ -20075,13 +23580,7 @@
   <p:cSld>
     <p:spTree>
       <p:nvGrpSpPr>
-        <p:cNvPr id="1" name="Shape 328">
-          <a:extLst>
-            <a:ext uri="{FF2B5EF4-FFF2-40B4-BE49-F238E27FC236}">
-              <a16:creationId xmlns:a16="http://schemas.microsoft.com/office/drawing/2014/main" id="{505F5346-EFD1-E363-B0E8-70B041F9D149}"/>
-            </a:ext>
-          </a:extLst>
-        </p:cNvPr>
+        <p:cNvPr id="1" name=""/>
         <p:cNvGrpSpPr/>
         <p:nvPr/>
       </p:nvGrpSpPr>
@@ -20095,104 +23594,83 @@
       </p:grpSpPr>
       <p:sp>
         <p:nvSpPr>
-          <p:cNvPr id="329" name="Google Shape;329;p35">
+          <p:cNvPr id="2" name="Título 1">
             <a:extLst>
               <a:ext uri="{FF2B5EF4-FFF2-40B4-BE49-F238E27FC236}">
-                <a16:creationId xmlns:a16="http://schemas.microsoft.com/office/drawing/2014/main" id="{EFE7F7D2-921F-FB5C-0BE3-0E92E4EBEA4F}"/>
+                <a16:creationId xmlns:a16="http://schemas.microsoft.com/office/drawing/2014/main" id="{D2CCFA5B-FF7B-EE63-77BB-9BC4E29C0B61}"/>
               </a:ext>
             </a:extLst>
           </p:cNvPr>
-          <p:cNvSpPr txBox="1">
+          <p:cNvSpPr>
             <a:spLocks noGrp="1"/>
           </p:cNvSpPr>
           <p:nvPr>
-            <p:ph type="ctrTitle"/>
+            <p:ph type="title"/>
           </p:nvPr>
         </p:nvSpPr>
-        <p:spPr>
-          <a:xfrm>
-            <a:off x="972300" y="1482800"/>
-            <a:ext cx="7199400" cy="1477200"/>
-          </a:xfrm>
-          <a:prstGeom prst="rect">
-            <a:avLst/>
-          </a:prstGeom>
-        </p:spPr>
+        <p:spPr/>
         <p:txBody>
-          <a:bodyPr spcFirstLastPara="1" wrap="square" lIns="91425" tIns="91425" rIns="91425" bIns="91425" anchor="b" anchorCtr="0">
-            <a:noAutofit/>
-          </a:bodyPr>
+          <a:bodyPr/>
           <a:lstStyle/>
           <a:p>
-            <a:pPr marL="0" lvl="0" indent="0" algn="l" rtl="0">
-              <a:spcBef>
-                <a:spcPts val="0"/>
-              </a:spcBef>
-              <a:spcAft>
-                <a:spcPts val="0"/>
-              </a:spcAft>
-              <a:buNone/>
-            </a:pPr>
-            <a:r>
-              <a:rPr lang="en" dirty="0"/>
-              <a:t>Alternativa B: Multimodal</a:t>
-            </a:r>
-            <a:endParaRPr dirty="0"/>
+            <a:endParaRPr lang="pt-BR"/>
           </a:p>
         </p:txBody>
       </p:sp>
       <p:sp>
         <p:nvSpPr>
-          <p:cNvPr id="330" name="Google Shape;330;p35">
+          <p:cNvPr id="3" name="Subtítulo 2">
             <a:extLst>
               <a:ext uri="{FF2B5EF4-FFF2-40B4-BE49-F238E27FC236}">
-                <a16:creationId xmlns:a16="http://schemas.microsoft.com/office/drawing/2014/main" id="{0570BF8F-EECA-65FE-7238-50380D30996E}"/>
+                <a16:creationId xmlns:a16="http://schemas.microsoft.com/office/drawing/2014/main" id="{12012A85-58F1-111A-AE49-D9A54077B682}"/>
               </a:ext>
             </a:extLst>
           </p:cNvPr>
-          <p:cNvSpPr txBox="1">
+          <p:cNvSpPr>
             <a:spLocks noGrp="1"/>
           </p:cNvSpPr>
           <p:nvPr>
             <p:ph type="subTitle" idx="1"/>
           </p:nvPr>
         </p:nvSpPr>
-        <p:spPr>
-          <a:xfrm>
-            <a:off x="972300" y="3239202"/>
-            <a:ext cx="7199400" cy="421500"/>
-          </a:xfrm>
-          <a:prstGeom prst="rect">
-            <a:avLst/>
-          </a:prstGeom>
-        </p:spPr>
+        <p:spPr/>
         <p:txBody>
-          <a:bodyPr spcFirstLastPara="1" wrap="square" lIns="91425" tIns="91425" rIns="91425" bIns="91425" anchor="t" anchorCtr="0">
-            <a:noAutofit/>
-          </a:bodyPr>
+          <a:bodyPr/>
           <a:lstStyle/>
           <a:p>
-            <a:pPr marL="0" lvl="0" indent="0" algn="l" rtl="0">
-              <a:spcBef>
-                <a:spcPts val="0"/>
-              </a:spcBef>
-              <a:spcAft>
-                <a:spcPts val="0"/>
-              </a:spcAft>
-              <a:buNone/>
-            </a:pPr>
-            <a:r>
-              <a:rPr lang="pt-BR" dirty="0"/>
-              <a:t>Integração entre trechos rodoviários e transporte por cabotagem</a:t>
-            </a:r>
-            <a:endParaRPr dirty="0"/>
+            <a:endParaRPr lang="pt-BR"/>
+          </a:p>
+        </p:txBody>
+      </p:sp>
+      <p:sp>
+        <p:nvSpPr>
+          <p:cNvPr id="4" name="Espaço Reservado para Imagem 3">
+            <a:extLst>
+              <a:ext uri="{FF2B5EF4-FFF2-40B4-BE49-F238E27FC236}">
+                <a16:creationId xmlns:a16="http://schemas.microsoft.com/office/drawing/2014/main" id="{BF137960-28CE-A4FF-7839-DA4676E2F92B}"/>
+              </a:ext>
+            </a:extLst>
+          </p:cNvPr>
+          <p:cNvSpPr>
+            <a:spLocks noGrp="1"/>
+          </p:cNvSpPr>
+          <p:nvPr>
+            <p:ph type="pic" idx="2"/>
+          </p:nvPr>
+        </p:nvSpPr>
+        <p:spPr/>
+        <p:txBody>
+          <a:bodyPr/>
+          <a:lstStyle/>
+          <a:p>
+            <a:endParaRPr lang="pt-BR"/>
           </a:p>
         </p:txBody>
       </p:sp>
     </p:spTree>
     <p:extLst>
       <p:ext uri="{BB962C8B-B14F-4D97-AF65-F5344CB8AC3E}">
-        <p14:creationId xmlns:p14="http://schemas.microsoft.com/office/powerpoint/2010/main" val="3533937004"/>
+        <p14:creationId xmlns:p14="http://schemas.microsoft.com/office/powerpoint/2010/main" val="793710259"/>
       </p:ext>
     </p:extLst>
   </p:cSld>

</xml_diff>